<commit_message>
Checkpoint before fixing access toggle
</commit_message>
<xml_diff>
--- a/sih26238.pptx
+++ b/sih26238.pptx
@@ -156,61 +156,213 @@
 </p:presentation>
 </file>
 
-<file path=ppt/revisionInfo.xml><?xml version="1.0" encoding="utf-8"?>
-<p1510:revInfo xmlns:a="http://schemas.openxmlformats.org/drawingml/2006/main" xmlns:r="http://schemas.openxmlformats.org/officeDocument/2006/relationships" xmlns:p1510="http://schemas.microsoft.com/office/powerpoint/2015/10/main">
-  <p1510:revLst>
-    <p1510:client id="{86597EC3-8A37-423B-9F90-327F1533C88B}" v="5" dt="2026-09-23T17:00:26.430"/>
-  </p1510:revLst>
-</p1510:revInfo>
-</file>
-
 <file path=ppt/changesInfos/changesInfo1.xml><?xml version="1.0" encoding="utf-8"?>
 <pc:chgInfo xmlns:a="http://schemas.openxmlformats.org/drawingml/2006/main" xmlns:r="http://schemas.openxmlformats.org/officeDocument/2006/relationships" xmlns:ac="http://schemas.microsoft.com/office/drawing/2013/main/command" xmlns:pc="http://schemas.microsoft.com/office/powerpoint/2013/main/command">
   <pc:docChgLst>
-    <pc:chgData name="UMAR FAROOK" userId="739779c1dc6863ce" providerId="LiveId" clId="{24839D6D-7CCD-4A64-8928-6F7451A19CE0}"/>
-    <pc:docChg chg="modSld">
-      <pc:chgData name="UMAR FAROOK" userId="739779c1dc6863ce" providerId="LiveId" clId="{24839D6D-7CCD-4A64-8928-6F7451A19CE0}" dt="2026-09-23T17:01:44.449" v="132" actId="1076"/>
+    <pc:chgData name="Guest User" providerId="Windows Live" clId="Web-{00000000-0000-0000-0000-000000000000}"/>
+    <pc:docChg chg="modSld modMainMaster">
+      <pc:chgData name="Guest User" userId="" providerId="Windows Live" clId="Web-{00000000-0000-0000-0000-000000000000}" dt="2026-09-23T18:22:57.997" v="1"/>
       <pc:docMkLst>
         <pc:docMk/>
       </pc:docMkLst>
+      <pc:sldChg chg="modTransition">
+        <pc:chgData name="Guest User" userId="" providerId="Windows Live" clId="Web-{00000000-0000-0000-0000-000000000000}" dt="2026-09-23T18:22:57.997" v="1"/>
+        <pc:sldMkLst>
+          <pc:docMk/>
+          <pc:sldMk cId="0" sldId="256"/>
+        </pc:sldMkLst>
+      </pc:sldChg>
+      <pc:sldChg chg="modTransition">
+        <pc:chgData name="Guest User" userId="" providerId="Windows Live" clId="Web-{00000000-0000-0000-0000-000000000000}" dt="2026-09-23T18:22:57.997" v="1"/>
+        <pc:sldMkLst>
+          <pc:docMk/>
+          <pc:sldMk cId="0" sldId="257"/>
+        </pc:sldMkLst>
+      </pc:sldChg>
+      <pc:sldChg chg="modTransition">
+        <pc:chgData name="Guest User" userId="" providerId="Windows Live" clId="Web-{00000000-0000-0000-0000-000000000000}" dt="2026-09-23T18:22:57.997" v="1"/>
+        <pc:sldMkLst>
+          <pc:docMk/>
+          <pc:sldMk cId="0" sldId="258"/>
+        </pc:sldMkLst>
+      </pc:sldChg>
+      <pc:sldChg chg="modTransition">
+        <pc:chgData name="Guest User" userId="" providerId="Windows Live" clId="Web-{00000000-0000-0000-0000-000000000000}" dt="2026-09-23T18:22:57.997" v="1"/>
+        <pc:sldMkLst>
+          <pc:docMk/>
+          <pc:sldMk cId="0" sldId="259"/>
+        </pc:sldMkLst>
+      </pc:sldChg>
+      <pc:sldChg chg="modTransition">
+        <pc:chgData name="Guest User" userId="" providerId="Windows Live" clId="Web-{00000000-0000-0000-0000-000000000000}" dt="2026-09-23T18:22:57.997" v="1"/>
+        <pc:sldMkLst>
+          <pc:docMk/>
+          <pc:sldMk cId="0" sldId="260"/>
+        </pc:sldMkLst>
+      </pc:sldChg>
+      <pc:sldChg chg="modTransition">
+        <pc:chgData name="Guest User" userId="" providerId="Windows Live" clId="Web-{00000000-0000-0000-0000-000000000000}" dt="2026-09-23T18:22:57.997" v="1"/>
+        <pc:sldMkLst>
+          <pc:docMk/>
+          <pc:sldMk cId="0" sldId="261"/>
+        </pc:sldMkLst>
+      </pc:sldChg>
+      <pc:sldMasterChg chg="modTransition modSldLayout">
+        <pc:chgData name="Guest User" userId="" providerId="Windows Live" clId="Web-{00000000-0000-0000-0000-000000000000}" dt="2026-09-23T18:22:57.997" v="1"/>
+        <pc:sldMasterMkLst>
+          <pc:docMk/>
+          <pc:sldMasterMk cId="0" sldId="2147483648"/>
+        </pc:sldMasterMkLst>
+        <pc:sldLayoutChg chg="modTransition">
+          <pc:chgData name="Guest User" userId="" providerId="Windows Live" clId="Web-{00000000-0000-0000-0000-000000000000}" dt="2026-09-23T18:22:57.997" v="1"/>
+          <pc:sldLayoutMkLst>
+            <pc:docMk/>
+            <pc:sldMasterMk cId="0" sldId="2147483648"/>
+            <pc:sldLayoutMk cId="0" sldId="2147483649"/>
+          </pc:sldLayoutMkLst>
+        </pc:sldLayoutChg>
+        <pc:sldLayoutChg chg="modTransition">
+          <pc:chgData name="Guest User" userId="" providerId="Windows Live" clId="Web-{00000000-0000-0000-0000-000000000000}" dt="2026-09-23T18:22:57.997" v="1"/>
+          <pc:sldLayoutMkLst>
+            <pc:docMk/>
+            <pc:sldMasterMk cId="0" sldId="2147483648"/>
+            <pc:sldLayoutMk cId="0" sldId="2147483650"/>
+          </pc:sldLayoutMkLst>
+        </pc:sldLayoutChg>
+        <pc:sldLayoutChg chg="modTransition">
+          <pc:chgData name="Guest User" userId="" providerId="Windows Live" clId="Web-{00000000-0000-0000-0000-000000000000}" dt="2026-09-23T18:22:57.997" v="1"/>
+          <pc:sldLayoutMkLst>
+            <pc:docMk/>
+            <pc:sldMasterMk cId="0" sldId="2147483648"/>
+            <pc:sldLayoutMk cId="0" sldId="2147483651"/>
+          </pc:sldLayoutMkLst>
+        </pc:sldLayoutChg>
+        <pc:sldLayoutChg chg="modTransition">
+          <pc:chgData name="Guest User" userId="" providerId="Windows Live" clId="Web-{00000000-0000-0000-0000-000000000000}" dt="2026-09-23T18:22:57.997" v="1"/>
+          <pc:sldLayoutMkLst>
+            <pc:docMk/>
+            <pc:sldMasterMk cId="0" sldId="2147483648"/>
+            <pc:sldLayoutMk cId="0" sldId="2147483652"/>
+          </pc:sldLayoutMkLst>
+        </pc:sldLayoutChg>
+        <pc:sldLayoutChg chg="modTransition">
+          <pc:chgData name="Guest User" userId="" providerId="Windows Live" clId="Web-{00000000-0000-0000-0000-000000000000}" dt="2026-09-23T18:22:57.997" v="1"/>
+          <pc:sldLayoutMkLst>
+            <pc:docMk/>
+            <pc:sldMasterMk cId="0" sldId="2147483648"/>
+            <pc:sldLayoutMk cId="0" sldId="2147483653"/>
+          </pc:sldLayoutMkLst>
+        </pc:sldLayoutChg>
+        <pc:sldLayoutChg chg="modTransition">
+          <pc:chgData name="Guest User" userId="" providerId="Windows Live" clId="Web-{00000000-0000-0000-0000-000000000000}" dt="2026-09-23T18:22:57.997" v="1"/>
+          <pc:sldLayoutMkLst>
+            <pc:docMk/>
+            <pc:sldMasterMk cId="0" sldId="2147483648"/>
+            <pc:sldLayoutMk cId="0" sldId="2147483654"/>
+          </pc:sldLayoutMkLst>
+        </pc:sldLayoutChg>
+        <pc:sldLayoutChg chg="modTransition">
+          <pc:chgData name="Guest User" userId="" providerId="Windows Live" clId="Web-{00000000-0000-0000-0000-000000000000}" dt="2026-09-23T18:22:57.997" v="1"/>
+          <pc:sldLayoutMkLst>
+            <pc:docMk/>
+            <pc:sldMasterMk cId="0" sldId="2147483648"/>
+            <pc:sldLayoutMk cId="0" sldId="2147483655"/>
+          </pc:sldLayoutMkLst>
+        </pc:sldLayoutChg>
+        <pc:sldLayoutChg chg="modTransition">
+          <pc:chgData name="Guest User" userId="" providerId="Windows Live" clId="Web-{00000000-0000-0000-0000-000000000000}" dt="2026-09-23T18:22:57.997" v="1"/>
+          <pc:sldLayoutMkLst>
+            <pc:docMk/>
+            <pc:sldMasterMk cId="0" sldId="2147483648"/>
+            <pc:sldLayoutMk cId="0" sldId="2147483656"/>
+          </pc:sldLayoutMkLst>
+        </pc:sldLayoutChg>
+        <pc:sldLayoutChg chg="modTransition">
+          <pc:chgData name="Guest User" userId="" providerId="Windows Live" clId="Web-{00000000-0000-0000-0000-000000000000}" dt="2026-09-23T18:22:57.997" v="1"/>
+          <pc:sldLayoutMkLst>
+            <pc:docMk/>
+            <pc:sldMasterMk cId="0" sldId="2147483648"/>
+            <pc:sldLayoutMk cId="0" sldId="2147483657"/>
+          </pc:sldLayoutMkLst>
+        </pc:sldLayoutChg>
+        <pc:sldLayoutChg chg="modTransition">
+          <pc:chgData name="Guest User" userId="" providerId="Windows Live" clId="Web-{00000000-0000-0000-0000-000000000000}" dt="2026-09-23T18:22:57.997" v="1"/>
+          <pc:sldLayoutMkLst>
+            <pc:docMk/>
+            <pc:sldMasterMk cId="0" sldId="2147483648"/>
+            <pc:sldLayoutMk cId="0" sldId="2147483658"/>
+          </pc:sldLayoutMkLst>
+        </pc:sldLayoutChg>
+        <pc:sldLayoutChg chg="modTransition">
+          <pc:chgData name="Guest User" userId="" providerId="Windows Live" clId="Web-{00000000-0000-0000-0000-000000000000}" dt="2026-09-23T18:22:57.997" v="1"/>
+          <pc:sldLayoutMkLst>
+            <pc:docMk/>
+            <pc:sldMasterMk cId="0" sldId="2147483648"/>
+            <pc:sldLayoutMk cId="0" sldId="2147483659"/>
+          </pc:sldLayoutMkLst>
+        </pc:sldLayoutChg>
+      </pc:sldMasterChg>
+    </pc:docChg>
+  </pc:docChgLst>
+  <pc:docChgLst>
+    <pc:chgData name="UMAR FAROOK" userId="739779c1dc6863ce" providerId="LiveId" clId="{24839D6D-7CCD-4A64-8928-6F7451A19CE0}"/>
+    <pc:docChg chg="undo custSel modSld">
+      <pc:chgData name="UMAR FAROOK" userId="739779c1dc6863ce" providerId="LiveId" clId="{24839D6D-7CCD-4A64-8928-6F7451A19CE0}" dt="2026-09-26T03:02:17.991" v="226" actId="113"/>
+      <pc:docMkLst>
+        <pc:docMk/>
+      </pc:docMkLst>
+      <pc:sldChg chg="modSp mod">
+        <pc:chgData name="UMAR FAROOK" userId="739779c1dc6863ce" providerId="LiveId" clId="{24839D6D-7CCD-4A64-8928-6F7451A19CE0}" dt="2026-09-26T03:02:17.991" v="226" actId="113"/>
+        <pc:sldMkLst>
+          <pc:docMk/>
+          <pc:sldMk cId="0" sldId="256"/>
+        </pc:sldMkLst>
+        <pc:spChg chg="mod">
+          <ac:chgData name="UMAR FAROOK" userId="739779c1dc6863ce" providerId="LiveId" clId="{24839D6D-7CCD-4A64-8928-6F7451A19CE0}" dt="2026-09-26T03:02:17.991" v="226" actId="113"/>
+          <ac:spMkLst>
+            <pc:docMk/>
+            <pc:sldMk cId="0" sldId="256"/>
+            <ac:spMk id="9" creationId="{00000000-0000-0000-0000-000000000000}"/>
+          </ac:spMkLst>
+        </pc:spChg>
+      </pc:sldChg>
+      <pc:sldChg chg="addSp delSp modSp mod">
+        <pc:chgData name="UMAR FAROOK" userId="739779c1dc6863ce" providerId="LiveId" clId="{24839D6D-7CCD-4A64-8928-6F7451A19CE0}" dt="2026-09-23T18:10:28.864" v="204" actId="20577"/>
+        <pc:sldMkLst>
+          <pc:docMk/>
+          <pc:sldMk cId="0" sldId="258"/>
+        </pc:sldMkLst>
+        <pc:spChg chg="add mod">
+          <ac:chgData name="UMAR FAROOK" userId="739779c1dc6863ce" providerId="LiveId" clId="{24839D6D-7CCD-4A64-8928-6F7451A19CE0}" dt="2026-09-23T18:09:54.138" v="186" actId="255"/>
+          <ac:spMkLst>
+            <pc:docMk/>
+            <pc:sldMk cId="0" sldId="258"/>
+            <ac:spMk id="13" creationId="{BBECB786-F5C3-1BFC-2DA9-1DA5C23D1CBB}"/>
+          </ac:spMkLst>
+        </pc:spChg>
+        <pc:spChg chg="add mod">
+          <ac:chgData name="UMAR FAROOK" userId="739779c1dc6863ce" providerId="LiveId" clId="{24839D6D-7CCD-4A64-8928-6F7451A19CE0}" dt="2026-09-23T18:10:28.864" v="204" actId="20577"/>
+          <ac:spMkLst>
+            <pc:docMk/>
+            <pc:sldMk cId="0" sldId="258"/>
+            <ac:spMk id="21" creationId="{D100EA45-C005-141E-EFFF-695AB9A4F2EC}"/>
+          </ac:spMkLst>
+        </pc:spChg>
+        <pc:spChg chg="mod">
+          <ac:chgData name="UMAR FAROOK" userId="739779c1dc6863ce" providerId="LiveId" clId="{24839D6D-7CCD-4A64-8928-6F7451A19CE0}" dt="2026-09-23T18:05:05.778" v="147" actId="1076"/>
+          <ac:spMkLst>
+            <pc:docMk/>
+            <pc:sldMk cId="0" sldId="258"/>
+            <ac:spMk id="43" creationId="{00000000-0000-0000-0000-000000000000}"/>
+          </ac:spMkLst>
+        </pc:spChg>
+      </pc:sldChg>
       <pc:sldChg chg="addSp delSp modSp mod">
         <pc:chgData name="UMAR FAROOK" userId="739779c1dc6863ce" providerId="LiveId" clId="{24839D6D-7CCD-4A64-8928-6F7451A19CE0}" dt="2026-09-23T17:01:44.449" v="132" actId="1076"/>
         <pc:sldMkLst>
           <pc:docMk/>
           <pc:sldMk cId="0" sldId="261"/>
         </pc:sldMkLst>
-        <pc:spChg chg="add del mod">
-          <ac:chgData name="UMAR FAROOK" userId="739779c1dc6863ce" providerId="LiveId" clId="{24839D6D-7CCD-4A64-8928-6F7451A19CE0}" dt="2026-09-23T16:57:01.494" v="8"/>
-          <ac:spMkLst>
-            <pc:docMk/>
-            <pc:sldMk cId="0" sldId="261"/>
-            <ac:spMk id="12" creationId="{41F72DF7-D9A5-F9A3-5A8A-2FB3A6131A1B}"/>
-          </ac:spMkLst>
-        </pc:spChg>
-        <pc:spChg chg="add del mod">
-          <ac:chgData name="UMAR FAROOK" userId="739779c1dc6863ce" providerId="LiveId" clId="{24839D6D-7CCD-4A64-8928-6F7451A19CE0}" dt="2026-09-23T16:57:04.161" v="11"/>
-          <ac:spMkLst>
-            <pc:docMk/>
-            <pc:sldMk cId="0" sldId="261"/>
-            <ac:spMk id="13" creationId="{DB87C993-9D6C-253F-3210-E36AC1700B07}"/>
-          </ac:spMkLst>
-        </pc:spChg>
-        <pc:spChg chg="add del mod">
-          <ac:chgData name="UMAR FAROOK" userId="739779c1dc6863ce" providerId="LiveId" clId="{24839D6D-7CCD-4A64-8928-6F7451A19CE0}" dt="2026-09-23T16:57:05.287" v="14"/>
-          <ac:spMkLst>
-            <pc:docMk/>
-            <pc:sldMk cId="0" sldId="261"/>
-            <ac:spMk id="19" creationId="{D4193F40-6DB4-2C87-37FE-D74D5A65F266}"/>
-          </ac:spMkLst>
-        </pc:spChg>
-        <pc:spChg chg="add del mod">
-          <ac:chgData name="UMAR FAROOK" userId="739779c1dc6863ce" providerId="LiveId" clId="{24839D6D-7CCD-4A64-8928-6F7451A19CE0}" dt="2026-09-23T16:59:34.805" v="70"/>
-          <ac:spMkLst>
-            <pc:docMk/>
-            <pc:sldMk cId="0" sldId="261"/>
-            <ac:spMk id="20" creationId="{F0919A91-EC95-0ECB-D096-AA5EB2F3BA2A}"/>
-          </ac:spMkLst>
-        </pc:spChg>
         <pc:spChg chg="add mod">
           <ac:chgData name="UMAR FAROOK" userId="739779c1dc6863ce" providerId="LiveId" clId="{24839D6D-7CCD-4A64-8928-6F7451A19CE0}" dt="2026-09-23T17:01:29.154" v="130" actId="1035"/>
           <ac:spMkLst>
@@ -1965,10 +2117,10 @@
         <a:lstStyle/>
         <a:p>
           <a:r>
-            <a:rPr lang="en-US" dirty="0"/>
+            <a:rPr lang="en-US"/>
             <a:t>Uses commonly available web/mobile technologies, databases and APIs.</a:t>
           </a:r>
-          <a:endParaRPr lang="en-IN" dirty="0"/>
+          <a:endParaRPr lang="en-IN"/>
         </a:p>
       </dgm:t>
     </dgm:pt>
@@ -2002,10 +2154,10 @@
         <a:lstStyle/>
         <a:p>
           <a:r>
-            <a:rPr lang="en-US" dirty="0"/>
+            <a:rPr lang="en-US"/>
             <a:t>The system can be connected with existing scholarship and digital-document services.</a:t>
           </a:r>
-          <a:endParaRPr lang="en-IN" dirty="0"/>
+          <a:endParaRPr lang="en-IN"/>
         </a:p>
       </dgm:t>
     </dgm:pt>
@@ -2039,10 +2191,10 @@
         <a:lstStyle/>
         <a:p>
           <a:r>
-            <a:rPr lang="en-US" dirty="0"/>
+            <a:rPr lang="en-US"/>
             <a:t>Student information and documents can be stored and managed securely.</a:t>
           </a:r>
-          <a:endParaRPr lang="en-IN" dirty="0"/>
+          <a:endParaRPr lang="en-IN"/>
         </a:p>
       </dgm:t>
     </dgm:pt>
@@ -2170,14 +2322,14 @@
             </a:spcAft>
           </a:pPr>
           <a:r>
-            <a:rPr lang="en-US" sz="1800" b="1" dirty="0"/>
+            <a:rPr lang="en-US" sz="1800" b="1"/>
             <a:t>Phase 1 — Build:</a:t>
           </a:r>
           <a:r>
-            <a:rPr lang="en-US" sz="1800" dirty="0"/>
+            <a:rPr lang="en-US" sz="1800"/>
             <a:t> Develop the student profile, scholarship search, document management and application tracking.</a:t>
           </a:r>
-          <a:endParaRPr lang="en-IN" sz="1800" dirty="0"/>
+          <a:endParaRPr lang="en-IN" sz="1800"/>
         </a:p>
       </dgm:t>
     </dgm:pt>
@@ -2222,14 +2374,14 @@
             </a:spcAft>
           </a:pPr>
           <a:r>
-            <a:rPr lang="en-US" sz="1900" b="1" dirty="0"/>
+            <a:rPr lang="en-US" sz="1900" b="1"/>
             <a:t>Phase 2 — Integrate:</a:t>
           </a:r>
           <a:r>
-            <a:rPr lang="en-US" sz="1900" dirty="0"/>
+            <a:rPr lang="en-US" sz="1900"/>
             <a:t> Connect with relevant government services and verification systems through authorized APIs.</a:t>
           </a:r>
-          <a:endParaRPr lang="en-IN" sz="1900" dirty="0"/>
+          <a:endParaRPr lang="en-IN" sz="1900"/>
         </a:p>
       </dgm:t>
     </dgm:pt>
@@ -2274,14 +2426,14 @@
             </a:spcAft>
           </a:pPr>
           <a:r>
-            <a:rPr lang="en-US" sz="1800" b="1" dirty="0"/>
+            <a:rPr lang="en-US" sz="1800" b="1"/>
             <a:t>Phase 3 — Test &amp; Deploy: </a:t>
           </a:r>
           <a:r>
-            <a:rPr lang="en-US" sz="1800" dirty="0"/>
+            <a:rPr lang="en-US" sz="1800"/>
             <a:t>Test with students and institutions, fix issues, and gradually expand the platform.</a:t>
           </a:r>
-          <a:endParaRPr lang="en-IN" sz="1800" dirty="0"/>
+          <a:endParaRPr lang="en-IN" sz="1800"/>
         </a:p>
       </dgm:t>
     </dgm:pt>
@@ -2458,10 +2610,10 @@
             <a:buNone/>
           </a:pPr>
           <a:r>
-            <a:rPr lang="en-US" sz="2100" kern="1200" dirty="0"/>
+            <a:rPr lang="en-US" sz="2100" kern="1200"/>
             <a:t>Uses commonly available web/mobile technologies, databases and APIs.</a:t>
           </a:r>
-          <a:endParaRPr lang="en-IN" sz="2100" kern="1200" dirty="0"/>
+          <a:endParaRPr lang="en-IN" sz="2100" kern="1200"/>
         </a:p>
       </dsp:txBody>
       <dsp:txXfrm>
@@ -2536,10 +2688,10 @@
             <a:buNone/>
           </a:pPr>
           <a:r>
-            <a:rPr lang="en-US" sz="2100" kern="1200" dirty="0"/>
+            <a:rPr lang="en-US" sz="2100" kern="1200"/>
             <a:t>The system can be connected with existing scholarship and digital-document services.</a:t>
           </a:r>
-          <a:endParaRPr lang="en-IN" sz="2100" kern="1200" dirty="0"/>
+          <a:endParaRPr lang="en-IN" sz="2100" kern="1200"/>
         </a:p>
       </dsp:txBody>
       <dsp:txXfrm>
@@ -2614,10 +2766,10 @@
             <a:buNone/>
           </a:pPr>
           <a:r>
-            <a:rPr lang="en-US" sz="2100" kern="1200" dirty="0"/>
+            <a:rPr lang="en-US" sz="2100" kern="1200"/>
             <a:t>Student information and documents can be stored and managed securely.</a:t>
           </a:r>
-          <a:endParaRPr lang="en-IN" sz="2100" kern="1200" dirty="0"/>
+          <a:endParaRPr lang="en-IN" sz="2100" kern="1200"/>
         </a:p>
       </dsp:txBody>
       <dsp:txXfrm>
@@ -2782,14 +2934,14 @@
             <a:buNone/>
           </a:pPr>
           <a:r>
-            <a:rPr lang="en-US" sz="1800" b="1" kern="1200" dirty="0"/>
+            <a:rPr lang="en-US" sz="1800" b="1" kern="1200"/>
             <a:t>Phase 1 — Build:</a:t>
           </a:r>
           <a:r>
-            <a:rPr lang="en-US" sz="1800" kern="1200" dirty="0"/>
+            <a:rPr lang="en-US" sz="1800" kern="1200"/>
             <a:t> Develop the student profile, scholarship search, document management and application tracking.</a:t>
           </a:r>
-          <a:endParaRPr lang="en-IN" sz="1800" kern="1200" dirty="0"/>
+          <a:endParaRPr lang="en-IN" sz="1800" kern="1200"/>
         </a:p>
       </dsp:txBody>
       <dsp:txXfrm>
@@ -2896,14 +3048,14 @@
             <a:buNone/>
           </a:pPr>
           <a:r>
-            <a:rPr lang="en-US" sz="1900" b="1" kern="1200" dirty="0"/>
+            <a:rPr lang="en-US" sz="1900" b="1" kern="1200"/>
             <a:t>Phase 2 — Integrate:</a:t>
           </a:r>
           <a:r>
-            <a:rPr lang="en-US" sz="1900" kern="1200" dirty="0"/>
+            <a:rPr lang="en-US" sz="1900" kern="1200"/>
             <a:t> Connect with relevant government services and verification systems through authorized APIs.</a:t>
           </a:r>
-          <a:endParaRPr lang="en-IN" sz="1900" kern="1200" dirty="0"/>
+          <a:endParaRPr lang="en-IN" sz="1900" kern="1200"/>
         </a:p>
       </dsp:txBody>
       <dsp:txXfrm>
@@ -3010,14 +3162,14 @@
             <a:buNone/>
           </a:pPr>
           <a:r>
-            <a:rPr lang="en-US" sz="1800" b="1" kern="1200" dirty="0"/>
+            <a:rPr lang="en-US" sz="1800" b="1" kern="1200"/>
             <a:t>Phase 3 — Test &amp; Deploy: </a:t>
           </a:r>
           <a:r>
-            <a:rPr lang="en-US" sz="1800" kern="1200" dirty="0"/>
+            <a:rPr lang="en-US" sz="1800" kern="1200"/>
             <a:t>Test with students and institutions, fix issues, and gradually expand the platform.</a:t>
           </a:r>
-          <a:endParaRPr lang="en-IN" sz="1800" kern="1200" dirty="0"/>
+          <a:endParaRPr lang="en-IN" sz="1800" kern="1200"/>
         </a:p>
       </dsp:txBody>
       <dsp:txXfrm>
@@ -5947,7 +6099,7 @@
           <a:p>
             <a:fld id="{1D8BD707-D9CF-40AE-B4C6-C98DA3205C09}" type="datetimeFigureOut">
               <a:rPr lang="en-US" smtClean="0"/>
-              <a:t>9/23/2026</a:t>
+              <a:t>9/26/2026</a:t>
             </a:fld>
             <a:endParaRPr lang="en-US"/>
           </a:p>
@@ -6000,9 +6152,6 @@
   <p:clrMapOvr>
     <a:masterClrMapping/>
   </p:clrMapOvr>
-  <p:transition spd="med">
-    <p:pull/>
-  </p:transition>
 </p:sldLayout>
 </file>
 
@@ -6113,7 +6262,7 @@
           <a:p>
             <a:fld id="{1D8BD707-D9CF-40AE-B4C6-C98DA3205C09}" type="datetimeFigureOut">
               <a:rPr lang="en-US" smtClean="0"/>
-              <a:t>9/23/2026</a:t>
+              <a:t>9/26/2026</a:t>
             </a:fld>
             <a:endParaRPr lang="en-US"/>
           </a:p>
@@ -6166,9 +6315,6 @@
   <p:clrMapOvr>
     <a:masterClrMapping/>
   </p:clrMapOvr>
-  <p:transition spd="med">
-    <p:pull/>
-  </p:transition>
 </p:sldLayout>
 </file>
 
@@ -6289,7 +6435,7 @@
           <a:p>
             <a:fld id="{1D8BD707-D9CF-40AE-B4C6-C98DA3205C09}" type="datetimeFigureOut">
               <a:rPr lang="en-US" smtClean="0"/>
-              <a:t>9/23/2026</a:t>
+              <a:t>9/26/2026</a:t>
             </a:fld>
             <a:endParaRPr lang="en-US"/>
           </a:p>
@@ -6342,9 +6488,6 @@
   <p:clrMapOvr>
     <a:masterClrMapping/>
   </p:clrMapOvr>
-  <p:transition spd="med">
-    <p:pull/>
-  </p:transition>
 </p:sldLayout>
 </file>
 
@@ -6455,7 +6598,7 @@
           <a:p>
             <a:fld id="{1D8BD707-D9CF-40AE-B4C6-C98DA3205C09}" type="datetimeFigureOut">
               <a:rPr lang="en-US" smtClean="0"/>
-              <a:t>9/23/2026</a:t>
+              <a:t>9/26/2026</a:t>
             </a:fld>
             <a:endParaRPr lang="en-US"/>
           </a:p>
@@ -6508,9 +6651,6 @@
   <p:clrMapOvr>
     <a:masterClrMapping/>
   </p:clrMapOvr>
-  <p:transition spd="med">
-    <p:pull/>
-  </p:transition>
 </p:sldLayout>
 </file>
 
@@ -6698,7 +6838,7 @@
           <a:p>
             <a:fld id="{1D8BD707-D9CF-40AE-B4C6-C98DA3205C09}" type="datetimeFigureOut">
               <a:rPr lang="en-US" smtClean="0"/>
-              <a:t>9/23/2026</a:t>
+              <a:t>9/26/2026</a:t>
             </a:fld>
             <a:endParaRPr lang="en-US"/>
           </a:p>
@@ -6751,9 +6891,6 @@
   <p:clrMapOvr>
     <a:masterClrMapping/>
   </p:clrMapOvr>
-  <p:transition spd="med">
-    <p:pull/>
-  </p:transition>
 </p:sldLayout>
 </file>
 
@@ -6981,7 +7118,7 @@
           <a:p>
             <a:fld id="{1D8BD707-D9CF-40AE-B4C6-C98DA3205C09}" type="datetimeFigureOut">
               <a:rPr lang="en-US" smtClean="0"/>
-              <a:t>9/23/2026</a:t>
+              <a:t>9/26/2026</a:t>
             </a:fld>
             <a:endParaRPr lang="en-US"/>
           </a:p>
@@ -7034,9 +7171,6 @@
   <p:clrMapOvr>
     <a:masterClrMapping/>
   </p:clrMapOvr>
-  <p:transition spd="med">
-    <p:pull/>
-  </p:transition>
 </p:sldLayout>
 </file>
 
@@ -7398,7 +7532,7 @@
           <a:p>
             <a:fld id="{1D8BD707-D9CF-40AE-B4C6-C98DA3205C09}" type="datetimeFigureOut">
               <a:rPr lang="en-US" smtClean="0"/>
-              <a:t>9/23/2026</a:t>
+              <a:t>9/26/2026</a:t>
             </a:fld>
             <a:endParaRPr lang="en-US"/>
           </a:p>
@@ -7451,9 +7585,6 @@
   <p:clrMapOvr>
     <a:masterClrMapping/>
   </p:clrMapOvr>
-  <p:transition spd="med">
-    <p:pull/>
-  </p:transition>
 </p:sldLayout>
 </file>
 
@@ -7513,7 +7644,7 @@
           <a:p>
             <a:fld id="{1D8BD707-D9CF-40AE-B4C6-C98DA3205C09}" type="datetimeFigureOut">
               <a:rPr lang="en-US" smtClean="0"/>
-              <a:t>9/23/2026</a:t>
+              <a:t>9/26/2026</a:t>
             </a:fld>
             <a:endParaRPr lang="en-US"/>
           </a:p>
@@ -7566,9 +7697,6 @@
   <p:clrMapOvr>
     <a:masterClrMapping/>
   </p:clrMapOvr>
-  <p:transition spd="med">
-    <p:pull/>
-  </p:transition>
 </p:sldLayout>
 </file>
 
@@ -7606,7 +7734,7 @@
           <a:p>
             <a:fld id="{1D8BD707-D9CF-40AE-B4C6-C98DA3205C09}" type="datetimeFigureOut">
               <a:rPr lang="en-US" smtClean="0"/>
-              <a:t>9/23/2026</a:t>
+              <a:t>9/26/2026</a:t>
             </a:fld>
             <a:endParaRPr lang="en-US"/>
           </a:p>
@@ -7659,9 +7787,6 @@
   <p:clrMapOvr>
     <a:masterClrMapping/>
   </p:clrMapOvr>
-  <p:transition spd="med">
-    <p:pull/>
-  </p:transition>
 </p:sldLayout>
 </file>
 
@@ -7879,7 +8004,7 @@
           <a:p>
             <a:fld id="{1D8BD707-D9CF-40AE-B4C6-C98DA3205C09}" type="datetimeFigureOut">
               <a:rPr lang="en-US" smtClean="0"/>
-              <a:t>9/23/2026</a:t>
+              <a:t>9/26/2026</a:t>
             </a:fld>
             <a:endParaRPr lang="en-US"/>
           </a:p>
@@ -7932,9 +8057,6 @@
   <p:clrMapOvr>
     <a:masterClrMapping/>
   </p:clrMapOvr>
-  <p:transition spd="med">
-    <p:pull/>
-  </p:transition>
 </p:sldLayout>
 </file>
 
@@ -8129,7 +8251,7 @@
           <a:p>
             <a:fld id="{1D8BD707-D9CF-40AE-B4C6-C98DA3205C09}" type="datetimeFigureOut">
               <a:rPr lang="en-US" smtClean="0"/>
-              <a:t>9/23/2026</a:t>
+              <a:t>9/26/2026</a:t>
             </a:fld>
             <a:endParaRPr lang="en-US"/>
           </a:p>
@@ -8182,9 +8304,6 @@
   <p:clrMapOvr>
     <a:masterClrMapping/>
   </p:clrMapOvr>
-  <p:transition spd="med">
-    <p:pull/>
-  </p:transition>
 </p:sldLayout>
 </file>
 
@@ -8338,7 +8457,7 @@
           <a:p>
             <a:fld id="{1D8BD707-D9CF-40AE-B4C6-C98DA3205C09}" type="datetimeFigureOut">
               <a:rPr lang="en-US" smtClean="0"/>
-              <a:t>9/23/2026</a:t>
+              <a:t>9/26/2026</a:t>
             </a:fld>
             <a:endParaRPr lang="en-US"/>
           </a:p>
@@ -8438,9 +8557,6 @@
     <p:sldLayoutId id="2147483658" r:id="rId10"/>
     <p:sldLayoutId id="2147483659" r:id="rId11"/>
   </p:sldLayoutIdLst>
-  <p:transition spd="med">
-    <p:pull/>
-  </p:transition>
   <p:txStyles>
     <p:titleStyle>
       <a:lvl1pPr algn="ctr" defTabSz="914400" rtl="0" eaLnBrk="1" latinLnBrk="0" hangingPunct="1">
@@ -8766,7 +8882,7 @@
           <a:bodyPr/>
           <a:lstStyle/>
           <a:p>
-            <a:endParaRPr lang="en-IN" dirty="0"/>
+            <a:endParaRPr lang="en-IN"/>
           </a:p>
         </p:txBody>
       </p:sp>
@@ -8835,7 +8951,7 @@
             <a:bodyPr/>
             <a:lstStyle/>
             <a:p>
-              <a:endParaRPr lang="en-IN" dirty="0"/>
+              <a:endParaRPr lang="en-IN"/>
             </a:p>
           </p:txBody>
         </p:sp>
@@ -8866,7 +8982,7 @@
                 <a:spcPts val="5760"/>
               </a:lnSpc>
             </a:pPr>
-            <a:endParaRPr dirty="0"/>
+            <a:endParaRPr/>
           </a:p>
           <a:p>
             <a:pPr algn="ctr">
@@ -8875,7 +8991,7 @@
               </a:lnSpc>
             </a:pPr>
             <a:r>
-              <a:rPr lang="en-US" sz="4800" b="1" dirty="0">
+              <a:rPr lang="en-US" sz="4800" b="1">
                 <a:solidFill>
                   <a:srgbClr val="000000"/>
                 </a:solidFill>
@@ -8951,7 +9067,7 @@
             <a:bodyPr/>
             <a:lstStyle/>
             <a:p>
-              <a:endParaRPr lang="en-IN" dirty="0"/>
+              <a:endParaRPr lang="en-IN"/>
             </a:p>
           </p:txBody>
         </p:sp>
@@ -8980,7 +9096,7 @@
                 </a:lnSpc>
               </a:pPr>
               <a:r>
-                <a:rPr lang="en-US" sz="6000" b="1" dirty="0">
+                <a:rPr lang="en-US" sz="6000" b="1">
                   <a:solidFill>
                     <a:srgbClr val="1F497D"/>
                   </a:solidFill>
@@ -9021,7 +9137,7 @@
                 <a:spcPts val="4320"/>
               </a:lnSpc>
             </a:pPr>
-            <a:endParaRPr dirty="0"/>
+            <a:endParaRPr/>
           </a:p>
           <a:p>
             <a:pPr marL="633730" lvl="1" indent="-316865" algn="just">
@@ -9032,7 +9148,7 @@
               <a:buChar char="•"/>
             </a:pPr>
             <a:r>
-              <a:rPr lang="en-US" sz="3500" b="1" dirty="0">
+              <a:rPr lang="en-US" sz="3500" b="1">
                 <a:solidFill>
                   <a:srgbClr val="000000"/>
                 </a:solidFill>
@@ -9041,7 +9157,19 @@
                 <a:cs typeface="Calibri" panose="020F0502020204030204" pitchFamily="34" charset="0"/>
                 <a:sym typeface="Arial Bold" panose="020B0704020202020204"/>
               </a:rPr>
-              <a:t>Problem Statement ID – 26238</a:t>
+              <a:t>Problem Statement ID – </a:t>
+            </a:r>
+            <a:r>
+              <a:rPr lang="en-US" sz="3500">
+                <a:solidFill>
+                  <a:srgbClr val="000000"/>
+                </a:solidFill>
+                <a:latin typeface="Calibri" panose="020F0502020204030204" pitchFamily="34" charset="0"/>
+                <a:ea typeface="Calibri" panose="020F0502020204030204" pitchFamily="34" charset="0"/>
+                <a:cs typeface="Calibri" panose="020F0502020204030204" pitchFamily="34" charset="0"/>
+                <a:sym typeface="Arial Bold" panose="020B0704020202020204"/>
+              </a:rPr>
+              <a:t>26238</a:t>
             </a:r>
           </a:p>
           <a:p>
@@ -9053,7 +9181,7 @@
               <a:buChar char="•"/>
             </a:pPr>
             <a:r>
-              <a:rPr lang="en-US" sz="3500" b="1" dirty="0">
+              <a:rPr lang="en-US" sz="3500" b="1">
                 <a:solidFill>
                   <a:srgbClr val="000000"/>
                 </a:solidFill>
@@ -9062,7 +9190,19 @@
                 <a:cs typeface="Calibri" panose="020F0502020204030204" pitchFamily="34" charset="0"/>
                 <a:sym typeface="Arial Bold" panose="020B0704020202020204"/>
               </a:rPr>
-              <a:t>Problem Statement Title- Unified Scholarship Mobile Application for Tribal Students</a:t>
+              <a:t>Problem Statement Title - </a:t>
+            </a:r>
+            <a:r>
+              <a:rPr lang="en-US" sz="3500">
+                <a:solidFill>
+                  <a:srgbClr val="000000"/>
+                </a:solidFill>
+                <a:latin typeface="Calibri" panose="020F0502020204030204" pitchFamily="34" charset="0"/>
+                <a:ea typeface="Calibri" panose="020F0502020204030204" pitchFamily="34" charset="0"/>
+                <a:cs typeface="Calibri" panose="020F0502020204030204" pitchFamily="34" charset="0"/>
+                <a:sym typeface="Arial Bold" panose="020B0704020202020204"/>
+              </a:rPr>
+              <a:t>Unified Scholarship Mobile Application for Tribal Students</a:t>
             </a:r>
           </a:p>
           <a:p>
@@ -9074,7 +9214,7 @@
               <a:buChar char="•"/>
             </a:pPr>
             <a:r>
-              <a:rPr lang="en-US" sz="3500" b="1" dirty="0">
+              <a:rPr lang="en-US" sz="3500" b="1">
                 <a:solidFill>
                   <a:srgbClr val="000000"/>
                 </a:solidFill>
@@ -9083,7 +9223,19 @@
                 <a:cs typeface="Calibri" panose="020F0502020204030204" pitchFamily="34" charset="0"/>
                 <a:sym typeface="Arial Bold" panose="020B0704020202020204"/>
               </a:rPr>
-              <a:t>Theme- Smart Automation</a:t>
+              <a:t>Theme</a:t>
+            </a:r>
+            <a:r>
+              <a:rPr lang="en-US" sz="3500">
+                <a:solidFill>
+                  <a:srgbClr val="000000"/>
+                </a:solidFill>
+                <a:latin typeface="Calibri" panose="020F0502020204030204" pitchFamily="34" charset="0"/>
+                <a:ea typeface="Calibri" panose="020F0502020204030204" pitchFamily="34" charset="0"/>
+                <a:cs typeface="Calibri" panose="020F0502020204030204" pitchFamily="34" charset="0"/>
+                <a:sym typeface="Arial Bold" panose="020B0704020202020204"/>
+              </a:rPr>
+              <a:t>- Smart Automation</a:t>
             </a:r>
           </a:p>
           <a:p>
@@ -9095,7 +9247,7 @@
               <a:buChar char="•"/>
             </a:pPr>
             <a:r>
-              <a:rPr lang="en-US" sz="3500" b="1" dirty="0">
+              <a:rPr lang="en-US" sz="3500" b="1">
                 <a:solidFill>
                   <a:srgbClr val="000000"/>
                 </a:solidFill>
@@ -9104,7 +9256,19 @@
                 <a:cs typeface="Calibri" panose="020F0502020204030204" pitchFamily="34" charset="0"/>
                 <a:sym typeface="Arial Bold" panose="020B0704020202020204"/>
               </a:rPr>
-              <a:t>PS Category- Software</a:t>
+              <a:t>PS Category- </a:t>
+            </a:r>
+            <a:r>
+              <a:rPr lang="en-US" sz="3500">
+                <a:solidFill>
+                  <a:srgbClr val="000000"/>
+                </a:solidFill>
+                <a:latin typeface="Calibri" panose="020F0502020204030204" pitchFamily="34" charset="0"/>
+                <a:ea typeface="Calibri" panose="020F0502020204030204" pitchFamily="34" charset="0"/>
+                <a:cs typeface="Calibri" panose="020F0502020204030204" pitchFamily="34" charset="0"/>
+                <a:sym typeface="Arial Bold" panose="020B0704020202020204"/>
+              </a:rPr>
+              <a:t>Software</a:t>
             </a:r>
           </a:p>
           <a:p>
@@ -9116,7 +9280,7 @@
               <a:buChar char="•"/>
             </a:pPr>
             <a:r>
-              <a:rPr lang="en-US" sz="3500" b="1" dirty="0">
+              <a:rPr lang="en-US" sz="3500" b="1">
                 <a:solidFill>
                   <a:srgbClr val="000000"/>
                 </a:solidFill>
@@ -9125,9 +9289,21 @@
                 <a:cs typeface="Calibri" panose="020F0502020204030204" pitchFamily="34" charset="0"/>
                 <a:sym typeface="Arial Bold" panose="020B0704020202020204"/>
               </a:rPr>
-              <a:t>Team ID-DCSIH1141</a:t>
+              <a:t>Team ID -</a:t>
             </a:r>
-            <a:endParaRPr lang="en-US" altLang="en-US" sz="3500" b="1" dirty="0">
+            <a:r>
+              <a:rPr lang="en-US" sz="3500">
+                <a:solidFill>
+                  <a:srgbClr val="000000"/>
+                </a:solidFill>
+                <a:latin typeface="Calibri" panose="020F0502020204030204" pitchFamily="34" charset="0"/>
+                <a:ea typeface="Calibri" panose="020F0502020204030204" pitchFamily="34" charset="0"/>
+                <a:cs typeface="Calibri" panose="020F0502020204030204" pitchFamily="34" charset="0"/>
+                <a:sym typeface="Arial Bold" panose="020B0704020202020204"/>
+              </a:rPr>
+              <a:t>DCSIH1141</a:t>
+            </a:r>
+            <a:endParaRPr lang="en-US" altLang="en-US" sz="3500">
               <a:solidFill>
                 <a:srgbClr val="000000"/>
               </a:solidFill>
@@ -9146,7 +9322,7 @@
               <a:buChar char="•"/>
             </a:pPr>
             <a:r>
-              <a:rPr lang="en-US" sz="3500" b="1" dirty="0">
+              <a:rPr lang="en-US" sz="3500" b="1">
                 <a:solidFill>
                   <a:srgbClr val="000000"/>
                 </a:solidFill>
@@ -9155,10 +9331,10 @@
                 <a:cs typeface="Calibri" panose="020F0502020204030204" pitchFamily="34" charset="0"/>
                 <a:sym typeface="Arial Bold" panose="020B0704020202020204"/>
               </a:rPr>
-              <a:t>Team Name - </a:t>
+              <a:t>Team Name </a:t>
             </a:r>
             <a:r>
-              <a:rPr lang="en-US" sz="3500" b="1" dirty="0" err="1">
+              <a:rPr lang="en-US" sz="3500">
                 <a:solidFill>
                   <a:srgbClr val="000000"/>
                 </a:solidFill>
@@ -9167,17 +9343,8 @@
                 <a:cs typeface="Calibri" panose="020F0502020204030204" pitchFamily="34" charset="0"/>
                 <a:sym typeface="Arial Bold" panose="020B0704020202020204"/>
               </a:rPr>
-              <a:t>Infinova</a:t>
+              <a:t>- INFINOVA</a:t>
             </a:r>
-            <a:endParaRPr lang="en-US" sz="3500" b="1" dirty="0">
-              <a:solidFill>
-                <a:srgbClr val="000000"/>
-              </a:solidFill>
-              <a:latin typeface="Calibri" panose="020F0502020204030204" pitchFamily="34" charset="0"/>
-              <a:ea typeface="Calibri" panose="020F0502020204030204" pitchFamily="34" charset="0"/>
-              <a:cs typeface="Calibri" panose="020F0502020204030204" pitchFamily="34" charset="0"/>
-              <a:sym typeface="Arial Bold" panose="020B0704020202020204"/>
-            </a:endParaRPr>
           </a:p>
         </p:txBody>
       </p:sp>
@@ -9244,7 +9411,7 @@
             <a:bodyPr/>
             <a:lstStyle/>
             <a:p>
-              <a:endParaRPr lang="en-IN" dirty="0"/>
+              <a:endParaRPr lang="en-IN"/>
             </a:p>
           </p:txBody>
         </p:sp>
@@ -9254,9 +9421,6 @@
   <p:clrMapOvr>
     <a:masterClrMapping/>
   </p:clrMapOvr>
-  <p:transition spd="med">
-    <p:pull/>
-  </p:transition>
 </p:sld>
 </file>
 
@@ -9338,11 +9502,11 @@
           <a:bodyPr/>
           <a:lstStyle/>
           <a:p>
-            <a:endParaRPr lang="en-IN" sz="2800" b="1" dirty="0"/>
+            <a:endParaRPr lang="en-IN" sz="2800" b="1"/>
           </a:p>
           <a:p>
             <a:r>
-              <a:rPr lang="en-IN" sz="2800" b="1" dirty="0">
+              <a:rPr lang="en-IN" sz="2800" b="1">
                 <a:latin typeface="Cambria" panose="02040503050406030204" pitchFamily="18" charset="0"/>
                 <a:ea typeface="Cambria" panose="02040503050406030204" pitchFamily="18" charset="0"/>
               </a:rPr>
@@ -9475,7 +9639,7 @@
             <a:bodyPr/>
             <a:lstStyle/>
             <a:p>
-              <a:endParaRPr lang="en-IN" dirty="0"/>
+              <a:endParaRPr lang="en-IN"/>
             </a:p>
           </p:txBody>
         </p:sp>
@@ -9503,7 +9667,7 @@
                   <a:spcPts val="6000"/>
                 </a:lnSpc>
               </a:pPr>
-              <a:endParaRPr dirty="0"/>
+              <a:endParaRPr/>
             </a:p>
             <a:p>
               <a:pPr algn="ctr">
@@ -9512,7 +9676,7 @@
                 </a:lnSpc>
               </a:pPr>
               <a:r>
-                <a:rPr lang="en-US" sz="5000" b="1" dirty="0">
+                <a:rPr lang="en-US" sz="5000" b="1">
                   <a:solidFill>
                     <a:srgbClr val="000000"/>
                   </a:solidFill>
@@ -9524,7 +9688,7 @@
                 <a:t>T</a:t>
               </a:r>
               <a:r>
-                <a:rPr lang="en-IN" altLang="en-US" sz="5000" b="1" dirty="0">
+                <a:rPr lang="en-IN" altLang="en-US" sz="5000" b="1">
                   <a:solidFill>
                     <a:srgbClr val="000000"/>
                   </a:solidFill>
@@ -9630,7 +9794,7 @@
                 </a:lnSpc>
               </a:pPr>
               <a:r>
-                <a:rPr lang="en-US" sz="1800" b="1" dirty="0">
+                <a:rPr lang="en-US" sz="1800" b="1">
                   <a:solidFill>
                     <a:srgbClr val="FFFFFF"/>
                   </a:solidFill>
@@ -9740,7 +9904,7 @@
               </a:lnSpc>
             </a:pPr>
             <a:r>
-              <a:rPr lang="en-US" sz="3500" b="1" dirty="0">
+              <a:rPr lang="en-US" sz="3500" b="1">
                 <a:solidFill>
                   <a:srgbClr val="000000"/>
                 </a:solidFill>
@@ -9752,7 +9916,7 @@
               <a:t>C</a:t>
             </a:r>
             <a:r>
-              <a:rPr lang="en-IN" altLang="en-US" sz="3500" b="1" dirty="0">
+              <a:rPr lang="en-IN" altLang="en-US" sz="3500" b="1">
                 <a:solidFill>
                   <a:srgbClr val="000000"/>
                 </a:solidFill>
@@ -9763,7 +9927,7 @@
               </a:rPr>
               <a:t>HALLENGES AND PROBLEMS</a:t>
             </a:r>
-            <a:endParaRPr lang="en-US" sz="3500" b="1" dirty="0">
+            <a:endParaRPr lang="en-US" sz="3500" b="1">
               <a:solidFill>
                 <a:srgbClr val="000000"/>
               </a:solidFill>
@@ -9779,7 +9943,7 @@
                 <a:spcPts val="4900"/>
               </a:lnSpc>
             </a:pPr>
-            <a:endParaRPr lang="en-US" sz="3500" b="1" dirty="0">
+            <a:endParaRPr lang="en-US" sz="3500" b="1">
               <a:solidFill>
                 <a:srgbClr val="000000"/>
               </a:solidFill>
@@ -9818,7 +9982,7 @@
               </a:lnSpc>
             </a:pPr>
             <a:r>
-              <a:rPr lang="en-US" sz="3500" b="1" dirty="0">
+              <a:rPr lang="en-US" sz="3500" b="1">
                 <a:solidFill>
                   <a:srgbClr val="000000"/>
                 </a:solidFill>
@@ -9830,7 +9994,7 @@
               <a:t>P</a:t>
             </a:r>
             <a:r>
-              <a:rPr lang="en-IN" altLang="en-US" sz="3500" b="1" dirty="0">
+              <a:rPr lang="en-IN" altLang="en-US" sz="3500" b="1">
                 <a:solidFill>
                   <a:srgbClr val="000000"/>
                 </a:solidFill>
@@ -9841,7 +10005,7 @@
               </a:rPr>
               <a:t>ROPOSED SOLUTION AND HOW IT SOLVES THE PROBLEM</a:t>
             </a:r>
-            <a:endParaRPr lang="en-US" sz="3500" b="1" dirty="0">
+            <a:endParaRPr lang="en-US" sz="3500" b="1">
               <a:solidFill>
                 <a:srgbClr val="000000"/>
               </a:solidFill>
@@ -9880,7 +10044,7 @@
               </a:lnSpc>
             </a:pPr>
             <a:r>
-              <a:rPr lang="en-IN" altLang="en-US" sz="3500" b="1" dirty="0">
+              <a:rPr lang="en-IN" altLang="en-US" sz="3500" b="1">
                 <a:solidFill>
                   <a:srgbClr val="000000"/>
                 </a:solidFill>
@@ -9891,7 +10055,7 @@
               </a:rPr>
               <a:t>INNOVATIONS AND UNIQUENESS</a:t>
             </a:r>
-            <a:endParaRPr lang="en-US" sz="3500" b="1" dirty="0">
+            <a:endParaRPr lang="en-US" sz="3500" b="1">
               <a:solidFill>
                 <a:srgbClr val="000000"/>
               </a:solidFill>
@@ -9952,7 +10116,7 @@
               <a:buChar char="•"/>
             </a:pPr>
             <a:r>
-              <a:rPr lang="en-US" sz="2400" b="1" dirty="0">
+              <a:rPr lang="en-US" sz="2400" b="1">
                 <a:solidFill>
                   <a:srgbClr val="000000"/>
                 </a:solidFill>
@@ -9973,7 +10137,7 @@
               <a:buChar char="•"/>
             </a:pPr>
             <a:r>
-              <a:rPr lang="en-US" sz="2400" b="1" dirty="0">
+              <a:rPr lang="en-US" sz="2400" b="1">
                 <a:solidFill>
                   <a:srgbClr val="000000"/>
                 </a:solidFill>
@@ -9994,7 +10158,7 @@
               <a:buChar char="•"/>
             </a:pPr>
             <a:r>
-              <a:rPr lang="en-US" sz="2400" b="1" dirty="0">
+              <a:rPr lang="en-US" sz="2400" b="1">
                 <a:solidFill>
                   <a:srgbClr val="000000"/>
                 </a:solidFill>
@@ -10005,7 +10169,7 @@
               </a:rPr>
               <a:t>Difficulty in understanding eligibility, deadlines and application status.</a:t>
             </a:r>
-            <a:endParaRPr lang="en-US" sz="2400" b="1" dirty="0">
+            <a:endParaRPr lang="en-US" sz="2400" b="1">
               <a:latin typeface="Cambria" panose="02040503050406030204" charset="0"/>
               <a:cs typeface="Cambria" panose="02040503050406030204" charset="0"/>
             </a:endParaRPr>
@@ -10060,7 +10224,7 @@
               <a:buFont typeface="Arial" panose="020B0604020202020204"/>
               <a:buChar char="•"/>
             </a:pPr>
-            <a:endParaRPr lang="en-US" sz="2500" b="1" dirty="0">
+            <a:endParaRPr lang="en-US" sz="2500" b="1">
               <a:solidFill>
                 <a:srgbClr val="000000"/>
               </a:solidFill>
@@ -10079,7 +10243,7 @@
               <a:buChar char="•"/>
             </a:pPr>
             <a:r>
-              <a:rPr lang="en-US" sz="2500" b="1" dirty="0">
+              <a:rPr lang="en-US" sz="2500" b="1">
                 <a:solidFill>
                   <a:srgbClr val="000000"/>
                 </a:solidFill>
@@ -10100,7 +10264,7 @@
               <a:buChar char="•"/>
             </a:pPr>
             <a:r>
-              <a:rPr lang="en-US" sz="2500" b="1" dirty="0">
+              <a:rPr lang="en-US" sz="2500" b="1">
                 <a:solidFill>
                   <a:srgbClr val="000000"/>
                 </a:solidFill>
@@ -10121,7 +10285,7 @@
               <a:buChar char="•"/>
             </a:pPr>
             <a:r>
-              <a:rPr lang="en-US" sz="2500" b="1" dirty="0">
+              <a:rPr lang="en-US" sz="2500" b="1">
                 <a:solidFill>
                   <a:srgbClr val="000000"/>
                 </a:solidFill>
@@ -10142,7 +10306,7 @@
               <a:buChar char="•"/>
             </a:pPr>
             <a:r>
-              <a:rPr lang="en-US" sz="2500" b="1" dirty="0">
+              <a:rPr lang="en-US" sz="2500" b="1">
                 <a:solidFill>
                   <a:srgbClr val="000000"/>
                 </a:solidFill>
@@ -10160,7 +10324,7 @@
                 <a:spcPts val="3500"/>
               </a:lnSpc>
             </a:pPr>
-            <a:endParaRPr lang="en-US" sz="2400" b="1" dirty="0">
+            <a:endParaRPr lang="en-US" sz="2400" b="1">
               <a:solidFill>
                 <a:srgbClr val="000000"/>
               </a:solidFill>
@@ -10172,7 +10336,7 @@
           </a:p>
           <a:p>
             <a:pPr algn="ctr"/>
-            <a:endParaRPr lang="en-US" sz="2400" b="1" dirty="0">
+            <a:endParaRPr lang="en-US" sz="2400" b="1">
               <a:latin typeface="Cambria" panose="02040503050406030204" charset="0"/>
               <a:cs typeface="Cambria" panose="02040503050406030204" charset="0"/>
             </a:endParaRPr>
@@ -10228,7 +10392,7 @@
               <a:buChar char="•"/>
             </a:pPr>
             <a:r>
-              <a:rPr lang="en-US" sz="2400" b="1" dirty="0">
+              <a:rPr lang="en-US" sz="2400" b="1">
                 <a:solidFill>
                   <a:srgbClr val="000000"/>
                 </a:solidFill>
@@ -10249,7 +10413,7 @@
               <a:buChar char="•"/>
             </a:pPr>
             <a:r>
-              <a:rPr lang="en-US" sz="2400" b="1" dirty="0">
+              <a:rPr lang="en-US" sz="2400" b="1">
                 <a:solidFill>
                   <a:srgbClr val="000000"/>
                 </a:solidFill>
@@ -10270,7 +10434,7 @@
               <a:buChar char="•"/>
             </a:pPr>
             <a:r>
-              <a:rPr lang="en-US" sz="2400" b="1" dirty="0">
+              <a:rPr lang="en-US" sz="2400" b="1">
                 <a:solidFill>
                   <a:srgbClr val="000000"/>
                 </a:solidFill>
@@ -10291,7 +10455,7 @@
               <a:buChar char="•"/>
             </a:pPr>
             <a:r>
-              <a:rPr lang="en-US" sz="2400" b="1" dirty="0">
+              <a:rPr lang="en-US" sz="2400" b="1">
                 <a:solidFill>
                   <a:srgbClr val="000000"/>
                 </a:solidFill>
@@ -10312,7 +10476,7 @@
               <a:buChar char="•"/>
             </a:pPr>
             <a:r>
-              <a:rPr lang="en-IN" altLang="en-US" sz="2400" b="1" dirty="0">
+              <a:rPr lang="en-IN" altLang="en-US" sz="2400" b="1">
                 <a:solidFill>
                   <a:srgbClr val="000000"/>
                 </a:solidFill>
@@ -10333,7 +10497,7 @@
               <a:buChar char="•"/>
             </a:pPr>
             <a:r>
-              <a:rPr lang="en-IN" altLang="en-US" sz="2400" b="1" dirty="0">
+              <a:rPr lang="en-IN" altLang="en-US" sz="2400" b="1">
                 <a:solidFill>
                   <a:srgbClr val="000000"/>
                 </a:solidFill>
@@ -10344,7 +10508,7 @@
               </a:rPr>
               <a:t>Secured document verification to reduce errors and fraud</a:t>
             </a:r>
-            <a:endParaRPr lang="en-US" sz="2400" b="1" dirty="0">
+            <a:endParaRPr lang="en-US" sz="2400" b="1">
               <a:solidFill>
                 <a:srgbClr val="000000"/>
               </a:solidFill>
@@ -10356,7 +10520,7 @@
           </a:p>
           <a:p>
             <a:pPr algn="ctr"/>
-            <a:endParaRPr lang="en-US" sz="2400" b="1" dirty="0">
+            <a:endParaRPr lang="en-US" sz="2400" b="1">
               <a:latin typeface="Cambria" panose="02040503050406030204" charset="0"/>
               <a:cs typeface="Cambria" panose="02040503050406030204" charset="0"/>
             </a:endParaRPr>
@@ -10368,9 +10532,6 @@
   <p:clrMapOvr>
     <a:masterClrMapping/>
   </p:clrMapOvr>
-  <p:transition spd="med">
-    <p:pull/>
-  </p:transition>
 </p:sld>
 </file>
 
@@ -10544,7 +10705,7 @@
                 </a:lnSpc>
               </a:pPr>
               <a:r>
-                <a:rPr lang="en-US" sz="5400" b="1" dirty="0">
+                <a:rPr lang="en-US" sz="5400" b="1">
                   <a:solidFill>
                     <a:srgbClr val="000000"/>
                   </a:solidFill>
@@ -10556,7 +10717,7 @@
                 <a:t>TECHNICAL </a:t>
               </a:r>
               <a:r>
-                <a:rPr lang="en-IN" altLang="en-US" sz="5400" b="1" dirty="0">
+                <a:rPr lang="en-IN" altLang="en-US" sz="5400" b="1">
                   <a:solidFill>
                     <a:srgbClr val="000000"/>
                   </a:solidFill>
@@ -10568,7 +10729,7 @@
                 <a:t> </a:t>
               </a:r>
               <a:r>
-                <a:rPr lang="en-US" sz="5400" b="1" dirty="0">
+                <a:rPr lang="en-US" sz="5400" b="1">
                   <a:solidFill>
                     <a:srgbClr val="000000"/>
                   </a:solidFill>
@@ -10714,7 +10875,7 @@
                 </a:lnSpc>
               </a:pPr>
               <a:r>
-                <a:rPr lang="en-US" sz="1800" b="1" dirty="0">
+                <a:rPr lang="en-US" sz="1800" b="1">
                   <a:solidFill>
                     <a:srgbClr val="FFFFFF"/>
                   </a:solidFill>
@@ -10833,7 +10994,7 @@
                 </a:lnSpc>
               </a:pPr>
               <a:r>
-                <a:rPr lang="en-IN" altLang="en-US" sz="2700" b="1" dirty="0">
+                <a:rPr lang="en-IN" altLang="en-US" sz="2700" b="1">
                   <a:solidFill>
                     <a:srgbClr val="000000"/>
                   </a:solidFill>
@@ -10958,23 +11119,23 @@
           <a:lstStyle/>
           <a:p>
             <a:pPr algn="ctr"/>
-            <a:endParaRPr lang="en-IN" altLang="en-US" dirty="0"/>
+            <a:endParaRPr lang="en-IN" altLang="en-US"/>
           </a:p>
           <a:p>
             <a:pPr algn="ctr"/>
-            <a:endParaRPr lang="en-IN" altLang="en-US" dirty="0"/>
+            <a:endParaRPr lang="en-IN" altLang="en-US"/>
           </a:p>
           <a:p>
             <a:pPr algn="ctr"/>
-            <a:endParaRPr lang="en-IN" altLang="en-US" dirty="0"/>
+            <a:endParaRPr lang="en-IN" altLang="en-US"/>
           </a:p>
           <a:p>
             <a:pPr algn="ctr"/>
-            <a:endParaRPr lang="en-IN" altLang="en-US" dirty="0"/>
+            <a:endParaRPr lang="en-IN" altLang="en-US"/>
           </a:p>
           <a:p>
             <a:pPr algn="ctr"/>
-            <a:endParaRPr lang="en-IN" altLang="en-US" sz="2200" b="1" dirty="0">
+            <a:endParaRPr lang="en-IN" altLang="en-US" sz="2200" b="1">
               <a:solidFill>
                 <a:schemeClr val="tx1"/>
               </a:solidFill>
@@ -10984,7 +11145,7 @@
           </a:p>
           <a:p>
             <a:pPr algn="ctr"/>
-            <a:endParaRPr lang="en-IN" altLang="en-US" sz="2600" b="1" dirty="0">
+            <a:endParaRPr lang="en-IN" altLang="en-US" sz="2600" b="1">
               <a:solidFill>
                 <a:schemeClr val="tx1"/>
               </a:solidFill>
@@ -10995,7 +11156,7 @@
           <a:p>
             <a:pPr algn="ctr"/>
             <a:r>
-              <a:rPr lang="en-IN" altLang="en-US" sz="2600" b="1" dirty="0">
+              <a:rPr lang="en-IN" altLang="en-US" sz="2600" b="1">
                 <a:solidFill>
                   <a:schemeClr val="tx1"/>
                 </a:solidFill>
@@ -11004,7 +11165,7 @@
               </a:rPr>
               <a:t>Flutter</a:t>
             </a:r>
-            <a:endParaRPr lang="en-IN" altLang="en-US" sz="2400" b="1" dirty="0">
+            <a:endParaRPr lang="en-IN" altLang="en-US" sz="2400" b="1">
               <a:solidFill>
                 <a:schemeClr val="tx1"/>
               </a:solidFill>
@@ -11014,7 +11175,7 @@
           </a:p>
           <a:p>
             <a:pPr algn="ctr"/>
-            <a:endParaRPr lang="en-IN" altLang="en-US" sz="2200" b="1" dirty="0">
+            <a:endParaRPr lang="en-IN" altLang="en-US" sz="2200" b="1">
               <a:solidFill>
                 <a:schemeClr val="tx1"/>
               </a:solidFill>
@@ -11025,7 +11186,7 @@
           <a:p>
             <a:pPr algn="ctr"/>
             <a:r>
-              <a:rPr lang="en-IN" altLang="en-US" sz="2200" b="1" dirty="0">
+              <a:rPr lang="en-IN" altLang="en-US" sz="2200" b="1">
                 <a:solidFill>
                   <a:schemeClr val="tx1"/>
                 </a:solidFill>
@@ -11038,7 +11199,7 @@
           <a:p>
             <a:pPr algn="ctr"/>
             <a:r>
-              <a:rPr lang="en-IN" altLang="en-US" sz="2200" b="1" dirty="0">
+              <a:rPr lang="en-IN" altLang="en-US" sz="2200" b="1">
                 <a:solidFill>
                   <a:schemeClr val="tx1"/>
                 </a:solidFill>
@@ -11208,29 +11369,29 @@
           <a:p>
             <a:pPr algn="ctr"/>
             <a:r>
-              <a:rPr lang="en-IN" altLang="en-US" dirty="0"/>
+              <a:rPr lang="en-IN" altLang="en-US"/>
               <a:t>0</a:t>
             </a:r>
           </a:p>
           <a:p>
             <a:pPr algn="ctr"/>
-            <a:endParaRPr lang="en-IN" altLang="en-US" dirty="0"/>
+            <a:endParaRPr lang="en-IN" altLang="en-US"/>
           </a:p>
           <a:p>
             <a:pPr algn="ctr"/>
-            <a:endParaRPr lang="en-IN" altLang="en-US" dirty="0"/>
+            <a:endParaRPr lang="en-IN" altLang="en-US"/>
           </a:p>
           <a:p>
             <a:pPr algn="ctr"/>
-            <a:endParaRPr lang="en-IN" altLang="en-US" dirty="0"/>
+            <a:endParaRPr lang="en-IN" altLang="en-US"/>
           </a:p>
           <a:p>
             <a:pPr algn="ctr"/>
-            <a:endParaRPr lang="en-IN" altLang="en-US" dirty="0"/>
+            <a:endParaRPr lang="en-IN" altLang="en-US"/>
           </a:p>
           <a:p>
             <a:pPr algn="ctr"/>
-            <a:endParaRPr lang="en-IN" altLang="en-US" sz="2200" b="1" dirty="0">
+            <a:endParaRPr lang="en-IN" altLang="en-US" sz="2200" b="1">
               <a:solidFill>
                 <a:schemeClr val="tx1"/>
               </a:solidFill>
@@ -11241,7 +11402,7 @@
           <a:p>
             <a:pPr algn="ctr"/>
             <a:r>
-              <a:rPr lang="en-IN" altLang="en-US" sz="2600" b="1" dirty="0">
+              <a:rPr lang="en-IN" altLang="en-US" sz="2600" b="1">
                 <a:solidFill>
                   <a:schemeClr val="tx1"/>
                 </a:solidFill>
@@ -11253,7 +11414,7 @@
           </a:p>
           <a:p>
             <a:pPr algn="ctr"/>
-            <a:endParaRPr lang="en-IN" altLang="en-US" sz="2200" b="1" dirty="0">
+            <a:endParaRPr lang="en-IN" altLang="en-US" sz="2200" b="1">
               <a:solidFill>
                 <a:schemeClr val="tx1"/>
               </a:solidFill>
@@ -11264,7 +11425,7 @@
           <a:p>
             <a:pPr algn="ctr"/>
             <a:r>
-              <a:rPr lang="en-IN" altLang="en-US" sz="2200" b="1" dirty="0">
+              <a:rPr lang="en-IN" altLang="en-US" sz="2200" b="1">
                 <a:solidFill>
                   <a:schemeClr val="tx1"/>
                 </a:solidFill>
@@ -11277,7 +11438,7 @@
           <a:p>
             <a:pPr algn="ctr"/>
             <a:r>
-              <a:rPr lang="en-IN" altLang="en-US" sz="2200" b="1" dirty="0">
+              <a:rPr lang="en-IN" altLang="en-US" sz="2200" b="1">
                 <a:solidFill>
                   <a:schemeClr val="tx1"/>
                 </a:solidFill>
@@ -11460,19 +11621,19 @@
           <a:lstStyle/>
           <a:p>
             <a:pPr algn="ctr"/>
-            <a:endParaRPr lang="en-US" dirty="0"/>
+            <a:endParaRPr lang="en-US"/>
           </a:p>
           <a:p>
             <a:pPr algn="ctr"/>
-            <a:endParaRPr lang="en-US" dirty="0"/>
+            <a:endParaRPr lang="en-US"/>
           </a:p>
           <a:p>
             <a:pPr algn="ctr"/>
-            <a:endParaRPr lang="en-US" dirty="0"/>
+            <a:endParaRPr lang="en-US"/>
           </a:p>
           <a:p>
             <a:pPr algn="ctr"/>
-            <a:endParaRPr lang="en-IN" altLang="en-US" sz="2600" b="1" dirty="0">
+            <a:endParaRPr lang="en-IN" altLang="en-US" sz="2600" b="1">
               <a:solidFill>
                 <a:schemeClr val="tx1"/>
               </a:solidFill>
@@ -11482,7 +11643,7 @@
           </a:p>
           <a:p>
             <a:pPr algn="ctr"/>
-            <a:endParaRPr lang="en-IN" altLang="en-US" sz="2600" b="1" dirty="0">
+            <a:endParaRPr lang="en-IN" altLang="en-US" sz="2600" b="1">
               <a:solidFill>
                 <a:schemeClr val="tx1"/>
               </a:solidFill>
@@ -11493,7 +11654,7 @@
           <a:p>
             <a:pPr algn="ctr"/>
             <a:r>
-              <a:rPr lang="en-IN" altLang="en-US" sz="2600" b="1" dirty="0">
+              <a:rPr lang="en-IN" altLang="en-US" sz="2600" b="1">
                 <a:solidFill>
                   <a:schemeClr val="tx1"/>
                 </a:solidFill>
@@ -11505,7 +11666,7 @@
           </a:p>
           <a:p>
             <a:pPr algn="ctr"/>
-            <a:endParaRPr lang="en-IN" altLang="en-US" sz="2600" b="1" dirty="0">
+            <a:endParaRPr lang="en-IN" altLang="en-US" sz="2600" b="1">
               <a:solidFill>
                 <a:schemeClr val="tx1"/>
               </a:solidFill>
@@ -11516,7 +11677,7 @@
           <a:p>
             <a:pPr algn="ctr"/>
             <a:r>
-              <a:rPr lang="en-IN" altLang="en-US" sz="2200" b="1" dirty="0">
+              <a:rPr lang="en-IN" altLang="en-US" sz="2200" b="1">
                 <a:solidFill>
                   <a:schemeClr val="tx1"/>
                 </a:solidFill>
@@ -11594,7 +11755,7 @@
           <a:p>
             <a:pPr algn="ctr"/>
             <a:r>
-              <a:rPr lang="en-IN" altLang="en-US" sz="3000" b="1" dirty="0">
+              <a:rPr lang="en-IN" altLang="en-US" sz="3000" b="1">
                 <a:solidFill>
                   <a:schemeClr val="tx2">
                     <a:lumMod val="20000"/>
@@ -11705,14 +11866,112 @@
           </a:prstGeom>
         </p:spPr>
       </p:pic>
+      <p:sp>
+        <p:nvSpPr>
+          <p:cNvPr id="13" name="TextBox 12">
+            <a:extLst>
+              <a:ext uri="{FF2B5EF4-FFF2-40B4-BE49-F238E27FC236}">
+                <a16:creationId xmlns:a16="http://schemas.microsoft.com/office/drawing/2014/main" id="{BBECB786-F5C3-1BFC-2DA9-1DA5C23D1CBB}"/>
+              </a:ext>
+            </a:extLst>
+          </p:cNvPr>
+          <p:cNvSpPr txBox="1"/>
+          <p:nvPr/>
+        </p:nvSpPr>
+        <p:spPr>
+          <a:xfrm>
+            <a:off x="13716000" y="2613109"/>
+            <a:ext cx="9144000" cy="477054"/>
+          </a:xfrm>
+          <a:prstGeom prst="rect">
+            <a:avLst/>
+          </a:prstGeom>
+          <a:noFill/>
+        </p:spPr>
+        <p:txBody>
+          <a:bodyPr wrap="square">
+            <a:spAutoFit/>
+          </a:bodyPr>
+          <a:lstStyle/>
+          <a:p>
+            <a:r>
+              <a:rPr lang="en-IN" sz="2500" b="1">
+                <a:latin typeface="Cambria" panose="02040503050406030204" pitchFamily="18" charset="0"/>
+                <a:ea typeface="Cambria" panose="02040503050406030204" pitchFamily="18" charset="0"/>
+                <a:hlinkClick r:id="rId9"/>
+              </a:rPr>
+              <a:t>Click Here </a:t>
+            </a:r>
+            <a:endParaRPr lang="en-IN" sz="2500" b="1">
+              <a:latin typeface="Cambria" panose="02040503050406030204" pitchFamily="18" charset="0"/>
+              <a:ea typeface="Cambria" panose="02040503050406030204" pitchFamily="18" charset="0"/>
+            </a:endParaRPr>
+          </a:p>
+        </p:txBody>
+      </p:sp>
+      <p:sp>
+        <p:nvSpPr>
+          <p:cNvPr id="21" name="TextBox 20">
+            <a:extLst>
+              <a:ext uri="{FF2B5EF4-FFF2-40B4-BE49-F238E27FC236}">
+                <a16:creationId xmlns:a16="http://schemas.microsoft.com/office/drawing/2014/main" id="{D100EA45-C005-141E-EFFF-695AB9A4F2EC}"/>
+              </a:ext>
+            </a:extLst>
+          </p:cNvPr>
+          <p:cNvSpPr txBox="1"/>
+          <p:nvPr/>
+        </p:nvSpPr>
+        <p:spPr>
+          <a:xfrm>
+            <a:off x="11197450" y="2646868"/>
+            <a:ext cx="2454198" cy="409536"/>
+          </a:xfrm>
+          <a:prstGeom prst="rect">
+            <a:avLst/>
+          </a:prstGeom>
+        </p:spPr>
+        <p:txBody>
+          <a:bodyPr wrap="none" lIns="0" tIns="0" rIns="0" bIns="0" rtlCol="0" anchor="t">
+            <a:spAutoFit/>
+          </a:bodyPr>
+          <a:lstStyle/>
+          <a:p>
+            <a:pPr marL="539750" indent="-269875" algn="just">
+              <a:lnSpc>
+                <a:spcPts val="3500"/>
+              </a:lnSpc>
+              <a:buFont typeface="Arial" panose="020B0604020202020204"/>
+              <a:buChar char="•"/>
+            </a:pPr>
+            <a:r>
+              <a:rPr lang="en-US" sz="2500" b="1">
+                <a:solidFill>
+                  <a:srgbClr val="000000"/>
+                </a:solidFill>
+                <a:latin typeface="Cambria" panose="02040503050406030204" pitchFamily="18" charset="0"/>
+                <a:ea typeface="Cambria" panose="02040503050406030204" pitchFamily="18" charset="0"/>
+                <a:cs typeface="Canva Sans" panose="020B0503030501040103"/>
+                <a:sym typeface="Canva Sans" panose="020B0503030501040103"/>
+              </a:rPr>
+              <a:t>Demo video :</a:t>
+            </a:r>
+            <a:endParaRPr lang="en-IN" sz="2500" b="1">
+              <a:solidFill>
+                <a:srgbClr val="000000"/>
+              </a:solidFill>
+              <a:latin typeface="Cambria" panose="02040503050406030204" pitchFamily="18" charset="0"/>
+              <a:ea typeface="Cambria" panose="02040503050406030204" pitchFamily="18" charset="0"/>
+              <a:cs typeface="Canva Sans" panose="020B0503030501040103"/>
+              <a:sym typeface="Canva Sans" panose="020B0503030501040103"/>
+            </a:endParaRPr>
+          </a:p>
+        </p:txBody>
+      </p:sp>
     </p:spTree>
   </p:cSld>
   <p:clrMapOvr>
     <a:masterClrMapping/>
   </p:clrMapOvr>
-  <p:transition spd="med">
-    <p:pull/>
-  </p:transition>
 </p:sld>
 </file>
 
@@ -11886,7 +12145,7 @@
                 </a:lnSpc>
               </a:pPr>
               <a:r>
-                <a:rPr lang="en-US" sz="5400" b="1" dirty="0">
+                <a:rPr lang="en-US" sz="5400" b="1">
                   <a:solidFill>
                     <a:srgbClr val="000000"/>
                   </a:solidFill>
@@ -11992,7 +12251,7 @@
                 </a:lnSpc>
               </a:pPr>
               <a:r>
-                <a:rPr lang="en-US" sz="1800" b="1" dirty="0">
+                <a:rPr lang="en-US" sz="1800" b="1">
                   <a:solidFill>
                     <a:srgbClr val="FFFFFF"/>
                   </a:solidFill>
@@ -12281,7 +12540,7 @@
               </a:lnSpc>
             </a:pPr>
             <a:r>
-              <a:rPr lang="en-IN" altLang="en-US" sz="3200" b="1" dirty="0">
+              <a:rPr lang="en-IN" altLang="en-US" sz="3200" b="1">
                 <a:solidFill>
                   <a:srgbClr val="000000"/>
                 </a:solidFill>
@@ -12293,7 +12552,7 @@
               <a:t>TECHNICAL FEASIBILITY</a:t>
             </a:r>
             <a:r>
-              <a:rPr lang="en-US" altLang="en-US" sz="3200" b="1" dirty="0">
+              <a:rPr lang="en-US" altLang="en-US" sz="3200" b="1">
                 <a:solidFill>
                   <a:srgbClr val="000000"/>
                 </a:solidFill>
@@ -12304,7 +12563,7 @@
               </a:rPr>
               <a:t>:</a:t>
             </a:r>
-            <a:endParaRPr lang="en-US" sz="3200" b="1" dirty="0">
+            <a:endParaRPr lang="en-US" sz="3200" b="1">
               <a:solidFill>
                 <a:srgbClr val="000000"/>
               </a:solidFill>
@@ -12359,7 +12618,7 @@
               </a:lnSpc>
             </a:pPr>
             <a:r>
-              <a:rPr lang="en-US" sz="3500" b="1" dirty="0">
+              <a:rPr lang="en-US" sz="3500" b="1">
                 <a:solidFill>
                   <a:srgbClr val="000000"/>
                 </a:solidFill>
@@ -12416,7 +12675,7 @@
               </a:lnSpc>
             </a:pPr>
             <a:r>
-              <a:rPr lang="en-US" sz="3000" b="1" dirty="0">
+              <a:rPr lang="en-US" sz="3000" b="1">
                 <a:solidFill>
                   <a:srgbClr val="000000"/>
                 </a:solidFill>
@@ -12428,7 +12687,7 @@
               <a:t>P</a:t>
             </a:r>
             <a:r>
-              <a:rPr lang="en-IN" altLang="en-US" sz="3000" b="1" dirty="0">
+              <a:rPr lang="en-IN" altLang="en-US" sz="3000" b="1">
                 <a:solidFill>
                   <a:srgbClr val="000000"/>
                 </a:solidFill>
@@ -12440,7 +12699,7 @@
               <a:t>OSSIBLE CHALLENGES AND SOLUTIONS</a:t>
             </a:r>
             <a:r>
-              <a:rPr lang="en-US" sz="3200" b="1" dirty="0">
+              <a:rPr lang="en-US" sz="3200" b="1">
                 <a:solidFill>
                   <a:srgbClr val="000000"/>
                 </a:solidFill>
@@ -12501,7 +12760,7 @@
                     <a:lstStyle/>
                     <a:p>
                       <a:r>
-                        <a:rPr lang="en-IN" sz="3600" dirty="0"/>
+                        <a:rPr lang="en-IN" sz="3600"/>
                         <a:t>Challenge</a:t>
                       </a:r>
                     </a:p>
@@ -12514,7 +12773,7 @@
                     <a:lstStyle/>
                     <a:p>
                       <a:r>
-                        <a:rPr lang="en-IN" sz="3600" dirty="0"/>
+                        <a:rPr lang="en-IN" sz="3600"/>
                         <a:t>Our Approach</a:t>
                       </a:r>
                     </a:p>
@@ -12534,7 +12793,7 @@
                     <a:lstStyle/>
                     <a:p>
                       <a:r>
-                        <a:rPr lang="en-IN" b="1" dirty="0"/>
+                        <a:rPr lang="en-IN" b="1"/>
                         <a:t>Different Government Systems</a:t>
                       </a:r>
                     </a:p>
@@ -12547,7 +12806,7 @@
                     <a:lstStyle/>
                     <a:p>
                       <a:r>
-                        <a:rPr lang="en-IN" b="1" dirty="0"/>
+                        <a:rPr lang="en-IN" b="1"/>
                         <a:t>Connect through APIs</a:t>
                       </a:r>
                     </a:p>
@@ -12567,7 +12826,7 @@
                     <a:lstStyle/>
                     <a:p>
                       <a:r>
-                        <a:rPr lang="en-IN" b="1" dirty="0"/>
+                        <a:rPr lang="en-IN" b="1"/>
                         <a:t>Document/Verification mismatch</a:t>
                       </a:r>
                     </a:p>
@@ -12580,7 +12839,7 @@
                     <a:lstStyle/>
                     <a:p>
                       <a:r>
-                        <a:rPr lang="en-IN" b="1" dirty="0"/>
+                        <a:rPr lang="en-IN" b="1"/>
                         <a:t>Manual Verification Mismatch</a:t>
                       </a:r>
                     </a:p>
@@ -12600,7 +12859,7 @@
                     <a:lstStyle/>
                     <a:p>
                       <a:r>
-                        <a:rPr lang="en-IN" b="1" dirty="0"/>
+                        <a:rPr lang="en-IN" b="1"/>
                         <a:t>Data Security</a:t>
                       </a:r>
                     </a:p>
@@ -12613,12 +12872,12 @@
                     <a:lstStyle/>
                     <a:p>
                       <a:r>
-                        <a:rPr lang="en-IN" b="1" i="0" dirty="0">
+                        <a:rPr lang="en-IN" b="1" i="0">
                           <a:effectLst/>
                         </a:rPr>
                         <a:t>Secure storage &amp; access control</a:t>
                       </a:r>
-                      <a:endParaRPr lang="en-IN" b="1" dirty="0"/>
+                      <a:endParaRPr lang="en-IN" b="1"/>
                     </a:p>
                   </a:txBody>
                   <a:tcPr/>
@@ -12636,12 +12895,12 @@
                     <a:lstStyle/>
                     <a:p>
                       <a:r>
-                        <a:rPr lang="en-IN" b="1" i="0" dirty="0">
+                        <a:rPr lang="en-IN" b="1" i="0">
                           <a:effectLst/>
                         </a:rPr>
                         <a:t>Different Languages</a:t>
                       </a:r>
-                      <a:endParaRPr lang="en-IN" b="1" dirty="0"/>
+                      <a:endParaRPr lang="en-IN" b="1"/>
                     </a:p>
                   </a:txBody>
                   <a:tcPr/>
@@ -12652,7 +12911,7 @@
                     <a:lstStyle/>
                     <a:p>
                       <a:r>
-                        <a:rPr lang="en-IN" b="1" dirty="0"/>
+                        <a:rPr lang="en-IN" b="1"/>
                         <a:t>Multilingual AI assistance</a:t>
                       </a:r>
                     </a:p>
@@ -12672,7 +12931,7 @@
                     <a:lstStyle/>
                     <a:p>
                       <a:r>
-                        <a:rPr lang="en-IN" b="1" dirty="0"/>
+                        <a:rPr lang="en-IN" b="1"/>
                         <a:t>Poor internet connectivity</a:t>
                       </a:r>
                     </a:p>
@@ -12685,7 +12944,7 @@
                     <a:lstStyle/>
                     <a:p>
                       <a:r>
-                        <a:rPr lang="en-IN" b="1" dirty="0"/>
+                        <a:rPr lang="en-IN" b="1"/>
                         <a:t>Lightweight , mobile-friendly design</a:t>
                       </a:r>
                     </a:p>
@@ -12733,7 +12992,7 @@
               <a:buFont typeface="Arial" panose="020B0604020202020204"/>
               <a:buNone/>
             </a:pPr>
-            <a:endParaRPr lang="en-IN" altLang="en-US" sz="3200" b="1" dirty="0">
+            <a:endParaRPr lang="en-IN" altLang="en-US" sz="3200" b="1">
               <a:solidFill>
                 <a:srgbClr val="000000"/>
               </a:solidFill>
@@ -12752,7 +13011,7 @@
               <a:buNone/>
             </a:pPr>
             <a:r>
-              <a:rPr lang="en-IN" altLang="en-US" sz="3200" b="1" dirty="0">
+              <a:rPr lang="en-IN" altLang="en-US" sz="3200" b="1">
                 <a:solidFill>
                   <a:srgbClr val="000000"/>
                 </a:solidFill>
@@ -12771,9 +13030,6 @@
   <p:clrMapOvr>
     <a:masterClrMapping/>
   </p:clrMapOvr>
-  <p:transition spd="med">
-    <p:pull/>
-  </p:transition>
 </p:sld>
 </file>
 
@@ -12870,7 +13126,7 @@
           <a:lstStyle/>
           <a:p>
             <a:pPr algn="ctr"/>
-            <a:endParaRPr lang="en-US" dirty="0"/>
+            <a:endParaRPr lang="en-US"/>
           </a:p>
         </p:txBody>
       </p:sp>
@@ -13027,7 +13283,7 @@
                 </a:lnSpc>
               </a:pPr>
               <a:r>
-                <a:rPr lang="en-US" sz="5400" b="1" dirty="0">
+                <a:rPr lang="en-US" sz="5400" b="1">
                   <a:solidFill>
                     <a:srgbClr val="000000"/>
                   </a:solidFill>
@@ -13133,7 +13389,7 @@
                 </a:lnSpc>
               </a:pPr>
               <a:r>
-                <a:rPr lang="en-US" sz="1800" b="1" dirty="0">
+                <a:rPr lang="en-US" sz="1800" b="1">
                   <a:solidFill>
                     <a:srgbClr val="FFFFFF"/>
                   </a:solidFill>
@@ -13304,7 +13560,7 @@
                 </a:lnSpc>
               </a:pPr>
               <a:r>
-                <a:rPr lang="en-IN" altLang="en-US" sz="2700" b="1" dirty="0">
+                <a:rPr lang="en-IN" altLang="en-US" sz="2700" b="1">
                   <a:solidFill>
                     <a:srgbClr val="000000"/>
                   </a:solidFill>
@@ -13428,7 +13684,7 @@
               </a:lnSpc>
             </a:pPr>
             <a:r>
-              <a:rPr lang="en-IN" altLang="en-US" sz="3500" b="1" dirty="0">
+              <a:rPr lang="en-IN" altLang="en-US" sz="3500" b="1">
                 <a:solidFill>
                   <a:srgbClr val="000000"/>
                 </a:solidFill>
@@ -13525,7 +13781,7 @@
               <a:buFont typeface="Arial" panose="020B0604020202020204"/>
               <a:buNone/>
             </a:pPr>
-            <a:endParaRPr lang="en-US" sz="2700" dirty="0">
+            <a:endParaRPr lang="en-US" sz="2700">
               <a:solidFill>
                 <a:srgbClr val="000000"/>
               </a:solidFill>
@@ -13544,7 +13800,7 @@
               <a:buChar char="•"/>
             </a:pPr>
             <a:r>
-              <a:rPr lang="en-US" sz="2800" dirty="0">
+              <a:rPr lang="en-US" sz="2800">
                 <a:solidFill>
                   <a:srgbClr val="000000"/>
                 </a:solidFill>
@@ -13565,7 +13821,7 @@
               <a:buChar char="•"/>
             </a:pPr>
             <a:r>
-              <a:rPr lang="en-US" sz="2800" dirty="0">
+              <a:rPr lang="en-US" sz="2800">
                 <a:solidFill>
                   <a:srgbClr val="000000"/>
                 </a:solidFill>
@@ -13586,7 +13842,7 @@
               <a:buChar char="•"/>
             </a:pPr>
             <a:r>
-              <a:rPr lang="en-US" sz="2800" dirty="0">
+              <a:rPr lang="en-US" sz="2800">
                 <a:solidFill>
                   <a:srgbClr val="000000"/>
                 </a:solidFill>
@@ -13626,7 +13882,7 @@
               <a:buFont typeface="Arial" panose="020B0604020202020204" pitchFamily="34" charset="0"/>
               <a:buNone/>
             </a:pPr>
-            <a:endParaRPr lang="en-GB" sz="2800" dirty="0"/>
+            <a:endParaRPr lang="en-GB" sz="2800"/>
           </a:p>
           <a:p>
             <a:pPr marL="342900" indent="-342900">
@@ -13634,7 +13890,7 @@
               <a:buChar char="•"/>
             </a:pPr>
             <a:r>
-              <a:rPr lang="en-GB" sz="2800" dirty="0">
+              <a:rPr lang="en-GB" sz="2800">
                 <a:latin typeface="Cambria" panose="02040503050406030204" charset="0"/>
                 <a:cs typeface="Cambria" panose="02040503050406030204" charset="0"/>
               </a:rPr>
@@ -13647,7 +13903,7 @@
               <a:buChar char="•"/>
             </a:pPr>
             <a:r>
-              <a:rPr lang="en-GB" sz="2800" dirty="0">
+              <a:rPr lang="en-GB" sz="2800">
                 <a:latin typeface="Cambria" panose="02040503050406030204" charset="0"/>
                 <a:cs typeface="Cambria" panose="02040503050406030204" charset="0"/>
               </a:rPr>
@@ -13660,7 +13916,7 @@
               <a:buChar char="•"/>
             </a:pPr>
             <a:r>
-              <a:rPr lang="en-GB" sz="2800" dirty="0">
+              <a:rPr lang="en-GB" sz="2800">
                 <a:latin typeface="Cambria" panose="02040503050406030204" charset="0"/>
                 <a:cs typeface="Cambria" panose="02040503050406030204" charset="0"/>
               </a:rPr>
@@ -13713,7 +13969,7 @@
               <a:buFont typeface="Arial" panose="020B0604020202020204" pitchFamily="34" charset="0"/>
               <a:buChar char="•"/>
             </a:pPr>
-            <a:endParaRPr lang="en-IN" altLang="en-US" dirty="0">
+            <a:endParaRPr lang="en-IN" altLang="en-US">
               <a:solidFill>
                 <a:schemeClr val="lt1"/>
               </a:solidFill>
@@ -13724,7 +13980,7 @@
               <a:buFont typeface="Arial" panose="020B0604020202020204" pitchFamily="34" charset="0"/>
               <a:buChar char="•"/>
             </a:pPr>
-            <a:endParaRPr lang="en-IN" altLang="en-US" dirty="0">
+            <a:endParaRPr lang="en-IN" altLang="en-US">
               <a:solidFill>
                 <a:schemeClr val="lt1"/>
               </a:solidFill>
@@ -13735,7 +13991,7 @@
               <a:buFont typeface="Arial" panose="020B0604020202020204" pitchFamily="34" charset="0"/>
               <a:buChar char="•"/>
             </a:pPr>
-            <a:endParaRPr lang="en-IN" altLang="en-US" dirty="0">
+            <a:endParaRPr lang="en-IN" altLang="en-US">
               <a:solidFill>
                 <a:schemeClr val="lt1"/>
               </a:solidFill>
@@ -13746,7 +14002,7 @@
               <a:buFont typeface="Arial" panose="020B0604020202020204" pitchFamily="34" charset="0"/>
               <a:buChar char="•"/>
             </a:pPr>
-            <a:endParaRPr lang="en-IN" altLang="en-US" sz="2800" dirty="0">
+            <a:endParaRPr lang="en-IN" altLang="en-US" sz="2800">
               <a:gradFill>
                 <a:gsLst>
                   <a:gs pos="50000">
@@ -13787,7 +14043,7 @@
               <a:buFont typeface="Arial" panose="020B0604020202020204" pitchFamily="34" charset="0"/>
               <a:buChar char="•"/>
             </a:pPr>
-            <a:endParaRPr lang="en-IN" altLang="en-US" sz="2800" dirty="0">
+            <a:endParaRPr lang="en-IN" altLang="en-US" sz="2800">
               <a:gradFill>
                 <a:gsLst>
                   <a:gs pos="50000">
@@ -13828,7 +14084,7 @@
               <a:buFont typeface="Arial" panose="020B0604020202020204" pitchFamily="34" charset="0"/>
               <a:buChar char="•"/>
             </a:pPr>
-            <a:endParaRPr lang="en-IN" altLang="en-US" sz="2800" dirty="0">
+            <a:endParaRPr lang="en-IN" altLang="en-US" sz="2800">
               <a:gradFill>
                 <a:gsLst>
                   <a:gs pos="50000">
@@ -13869,7 +14125,7 @@
               <a:buFont typeface="Arial" panose="020B0604020202020204" pitchFamily="34" charset="0"/>
               <a:buChar char="•"/>
             </a:pPr>
-            <a:endParaRPr lang="en-IN" altLang="en-US" sz="2800" dirty="0">
+            <a:endParaRPr lang="en-IN" altLang="en-US" sz="2800">
               <a:gradFill>
                 <a:gsLst>
                   <a:gs pos="50000">
@@ -13910,7 +14166,7 @@
               <a:buFont typeface="Arial" panose="020B0604020202020204" pitchFamily="34" charset="0"/>
               <a:buChar char="•"/>
             </a:pPr>
-            <a:endParaRPr lang="en-IN" altLang="en-US" sz="2800" dirty="0">
+            <a:endParaRPr lang="en-IN" altLang="en-US" sz="2800">
               <a:gradFill>
                 <a:gsLst>
                   <a:gs pos="50000">
@@ -13951,7 +14207,7 @@
               <a:buFont typeface="Arial" panose="020B0604020202020204" pitchFamily="34" charset="0"/>
               <a:buChar char="•"/>
             </a:pPr>
-            <a:endParaRPr lang="en-IN" altLang="en-US" sz="2800" dirty="0">
+            <a:endParaRPr lang="en-IN" altLang="en-US" sz="2800">
               <a:gradFill>
                 <a:gsLst>
                   <a:gs pos="50000">
@@ -13993,7 +14249,7 @@
               <a:buChar char="•"/>
             </a:pPr>
             <a:r>
-              <a:rPr lang="en-IN" altLang="en-US" sz="2800" dirty="0">
+              <a:rPr lang="en-IN" altLang="en-US" sz="2800">
                 <a:gradFill>
                   <a:gsLst>
                     <a:gs pos="50000">
@@ -14037,7 +14293,7 @@
               <a:buChar char="•"/>
             </a:pPr>
             <a:r>
-              <a:rPr lang="en-IN" altLang="en-US" sz="2800" dirty="0">
+              <a:rPr lang="en-IN" altLang="en-US" sz="2800">
                 <a:gradFill>
                   <a:gsLst>
                     <a:gs pos="50000">
@@ -14067,7 +14323,7 @@
               <a:buChar char="•"/>
             </a:pPr>
             <a:r>
-              <a:rPr lang="en-IN" altLang="en-US" sz="2800" dirty="0">
+              <a:rPr lang="en-IN" altLang="en-US" sz="2800">
                 <a:gradFill>
                   <a:gsLst>
                     <a:gs pos="50000">
@@ -14091,7 +14347,7 @@
               <a:t>Reduce delays and duplicate applications</a:t>
             </a:r>
             <a:r>
-              <a:rPr lang="en-IN" altLang="en-US" sz="2800" dirty="0">
+              <a:rPr lang="en-IN" altLang="en-US" sz="2800">
                 <a:solidFill>
                   <a:schemeClr val="lt1"/>
                 </a:solidFill>
@@ -14141,7 +14397,7 @@
           <a:p>
             <a:pPr algn="ctr"/>
             <a:r>
-              <a:rPr lang="en-IN" altLang="en-US" sz="3500" b="1" dirty="0">
+              <a:rPr lang="en-IN" altLang="en-US" sz="3500" b="1">
                 <a:solidFill>
                   <a:schemeClr val="tx1"/>
                 </a:solidFill>
@@ -14375,9 +14631,6 @@
   <p:clrMapOvr>
     <a:masterClrMapping/>
   </p:clrMapOvr>
-  <p:transition spd="med">
-    <p:pull/>
-  </p:transition>
 </p:sld>
 </file>
 
@@ -14657,7 +14910,7 @@
                 </a:lnSpc>
               </a:pPr>
               <a:r>
-                <a:rPr lang="en-US" sz="1800" b="1" dirty="0">
+                <a:rPr lang="en-US" sz="1800" b="1">
                   <a:solidFill>
                     <a:srgbClr val="FFFFFF"/>
                   </a:solidFill>
@@ -14776,7 +15029,7 @@
                 </a:lnSpc>
               </a:pPr>
               <a:r>
-                <a:rPr lang="en-IN" altLang="en-US" sz="2700" b="1" dirty="0">
+                <a:rPr lang="en-IN" altLang="en-US" sz="2700" b="1">
                   <a:solidFill>
                     <a:srgbClr val="000000"/>
                   </a:solidFill>
@@ -14888,7 +15141,7 @@
               <a:buNone/>
             </a:pPr>
             <a:r>
-              <a:rPr lang="en-US" altLang="en-US" sz="3000" b="1" dirty="0">
+              <a:rPr lang="en-US" altLang="en-US" sz="3000" b="1">
                 <a:solidFill>
                   <a:srgbClr val="000000"/>
                 </a:solidFill>
@@ -14909,7 +15162,7 @@
               <a:buChar char="•"/>
             </a:pPr>
             <a:r>
-              <a:rPr lang="en-US" altLang="en-US" sz="2800" dirty="0">
+              <a:rPr lang="en-US" altLang="en-US" sz="2800">
                 <a:solidFill>
                   <a:srgbClr val="000000"/>
                 </a:solidFill>
@@ -14921,7 +15174,7 @@
               </a:rPr>
               <a:t>https://tribal.nic.in/scholarshiP.apsx</a:t>
             </a:r>
-            <a:endParaRPr lang="en-US" altLang="en-US" sz="2800" dirty="0">
+            <a:endParaRPr lang="en-US" altLang="en-US" sz="2800">
               <a:solidFill>
                 <a:srgbClr val="000000"/>
               </a:solidFill>
@@ -14962,7 +15215,7 @@
               <a:buNone/>
             </a:pPr>
             <a:r>
-              <a:rPr lang="en-US" altLang="en-US" sz="3000" b="1" dirty="0">
+              <a:rPr lang="en-US" altLang="en-US" sz="3000" b="1">
                 <a:solidFill>
                   <a:srgbClr val="000000"/>
                 </a:solidFill>
@@ -14983,7 +15236,7 @@
               <a:buChar char="•"/>
             </a:pPr>
             <a:r>
-              <a:rPr lang="en-US" altLang="en-US" sz="2800" dirty="0">
+              <a:rPr lang="en-US" altLang="en-US" sz="2800">
                 <a:solidFill>
                   <a:srgbClr val="000000"/>
                 </a:solidFill>
@@ -14995,7 +15248,7 @@
               </a:rPr>
               <a:t>https://overseas.tribal.gov.in</a:t>
             </a:r>
-            <a:endParaRPr lang="en-US" altLang="en-US" sz="2800" dirty="0">
+            <a:endParaRPr lang="en-US" altLang="en-US" sz="2800">
               <a:solidFill>
                 <a:srgbClr val="000000"/>
               </a:solidFill>
@@ -15036,7 +15289,7 @@
               <a:buNone/>
             </a:pPr>
             <a:r>
-              <a:rPr lang="en-US" altLang="en-US" sz="3000" b="1" dirty="0">
+              <a:rPr lang="en-US" altLang="en-US" sz="3000" b="1">
                 <a:solidFill>
                   <a:srgbClr val="000000"/>
                 </a:solidFill>
@@ -15057,7 +15310,7 @@
               <a:buChar char="•"/>
             </a:pPr>
             <a:r>
-              <a:rPr lang="en-US" altLang="en-US" sz="2800" dirty="0">
+              <a:rPr lang="en-US" altLang="en-US" sz="2800">
                 <a:solidFill>
                   <a:srgbClr val="000000"/>
                 </a:solidFill>
@@ -15069,7 +15322,7 @@
               </a:rPr>
               <a:t>https://dbttribal.gov.in</a:t>
             </a:r>
-            <a:endParaRPr lang="en-US" altLang="en-US" sz="2800" dirty="0">
+            <a:endParaRPr lang="en-US" altLang="en-US" sz="2800">
               <a:solidFill>
                 <a:srgbClr val="000000"/>
               </a:solidFill>
@@ -15110,7 +15363,7 @@
               <a:buNone/>
             </a:pPr>
             <a:r>
-              <a:rPr lang="en-US" altLang="en-US" sz="3000" b="1" dirty="0">
+              <a:rPr lang="en-US" altLang="en-US" sz="3000" b="1">
                 <a:solidFill>
                   <a:srgbClr val="000000"/>
                 </a:solidFill>
@@ -15131,7 +15384,7 @@
               <a:buChar char="•"/>
             </a:pPr>
             <a:r>
-              <a:rPr lang="en-US" altLang="en-US" sz="2800" dirty="0">
+              <a:rPr lang="en-US" altLang="en-US" sz="2800">
                 <a:solidFill>
                   <a:srgbClr val="000000"/>
                 </a:solidFill>
@@ -15143,7 +15396,7 @@
               </a:rPr>
               <a:t>https://fellowship.tribal.gov.in</a:t>
             </a:r>
-            <a:endParaRPr lang="en-US" altLang="en-US" sz="2800" dirty="0">
+            <a:endParaRPr lang="en-US" altLang="en-US" sz="2800">
               <a:solidFill>
                 <a:srgbClr val="000000"/>
               </a:solidFill>
@@ -15184,7 +15437,7 @@
               <a:buNone/>
             </a:pPr>
             <a:r>
-              <a:rPr lang="en-US" altLang="en-US" sz="3000" b="1" dirty="0">
+              <a:rPr lang="en-US" altLang="en-US" sz="3000" b="1">
                 <a:solidFill>
                   <a:srgbClr val="000000"/>
                 </a:solidFill>
@@ -15205,7 +15458,7 @@
               <a:buChar char="•"/>
             </a:pPr>
             <a:r>
-              <a:rPr lang="en-US" altLang="en-US" sz="2800" dirty="0">
+              <a:rPr lang="en-US" altLang="en-US" sz="2800">
                 <a:solidFill>
                   <a:srgbClr val="000000"/>
                 </a:solidFill>
@@ -15217,7 +15470,7 @@
               </a:rPr>
               <a:t>https://scholarships.gov.in</a:t>
             </a:r>
-            <a:endParaRPr lang="en-US" altLang="en-US" sz="2800" dirty="0">
+            <a:endParaRPr lang="en-US" altLang="en-US" sz="2800">
               <a:solidFill>
                 <a:srgbClr val="000000"/>
               </a:solidFill>
@@ -15339,7 +15592,7 @@
               </a:lnSpc>
             </a:pPr>
             <a:r>
-              <a:rPr lang="en-US" sz="2500" b="1" dirty="0">
+              <a:rPr lang="en-US" sz="2500" b="1">
                 <a:solidFill>
                   <a:srgbClr val="000000"/>
                 </a:solidFill>
@@ -15350,7 +15603,7 @@
               </a:rPr>
               <a:t>Discover our solution</a:t>
             </a:r>
-            <a:endParaRPr lang="en-IN" sz="2500" b="1" dirty="0">
+            <a:endParaRPr lang="en-IN" sz="2500" b="1">
               <a:solidFill>
                 <a:srgbClr val="000000"/>
               </a:solidFill>
@@ -15367,9 +15620,6 @@
   <p:clrMapOvr>
     <a:masterClrMapping/>
   </p:clrMapOvr>
-  <p:transition spd="med">
-    <p:pull/>
-  </p:transition>
 </p:sld>
 </file>
 

</xml_diff>